<commit_message>
Collateral: rebuild with SOLUTIONS PVT LTD logo, update alt text
Co-Authored-By: Claude Opus 5.5 <noreply@anthropic.com>
</commit_message>
<xml_diff>
--- a/collateral/VShark-Presentation.pptx
+++ b/collateral/VShark-Presentation.pptx
@@ -123,13 +123,13 @@
   <p:extLst>
     <p:ext uri="{521415D9-36F7-43E2-AB2F-B90AF26B5E84}">
       <p14:sectionLst xmlns:p14="http://schemas.microsoft.com/office/powerpoint/2010/main">
-        <p14:section name="Introduction" id="{c9b3451a-0342-2b86-bc87-49f469f649c1}">
+        <p14:section name="Introduction" id="{687d534e-d168-4540-a55b-2f84193309ba}">
           <p14:sldIdLst>
             <p14:sldId id="256"/>
             <p14:sldId id="257"/>
           </p14:sldIdLst>
         </p14:section>
-        <p14:section name="Services" id="{948d8d52-9b96-2233-7ab1-7d6e70346be2}">
+        <p14:section name="Services" id="{ce9bf24c-9665-dd69-af2d-4d918050c93c}">
           <p14:sldIdLst>
             <p14:sldId id="258"/>
             <p14:sldId id="259"/>
@@ -142,19 +142,19 @@
             <p14:sldId id="266"/>
           </p14:sldIdLst>
         </p14:section>
-        <p14:section name="Portfolio" id="{ece30508-5cc3-7a35-391d-055d296e0c8b}">
+        <p14:section name="Portfolio" id="{fdf041f5-84c7-00ce-2fdb-676e27becbc5}">
           <p14:sldIdLst>
             <p14:sldId id="267"/>
             <p14:sldId id="268"/>
           </p14:sldIdLst>
         </p14:section>
-        <p14:section name="Industries &amp; products" id="{a40c2b75-cb7b-7c08-eae9-86e8579f83a6}">
+        <p14:section name="Industries &amp; products" id="{bd59a0d3-9881-0885-f425-b4cf99e82bbe}">
           <p14:sldIdLst>
             <p14:sldId id="269"/>
             <p14:sldId id="270"/>
           </p14:sldIdLst>
         </p14:section>
-        <p14:section name="Clients &amp; contact" id="{eeaab5c2-e279-3a43-97a1-f358e54533f0}">
+        <p14:section name="Clients &amp; contact" id="{dc37a638-a47f-1d23-ea44-77511b511aab}">
           <p14:sldIdLst>
             <p14:sldId id="271"/>
             <p14:sldId id="272"/>

</xml_diff>

<commit_message>
Collateral: rebuild with updated service data
- Deliverables follow the confirmed facts (no native CAD lines); process
  step reads 'CAD files' instead of 'Native files'
- Portfolio images chosen by file name (the site's portfolio was reworked)
- Deck mosaic no longer overflows when an image is taller

Co-Authored-By: Claude Opus 5.5 <noreply@anthropic.com>
</commit_message>
<xml_diff>
--- a/collateral/VShark-Presentation.pptx
+++ b/collateral/VShark-Presentation.pptx
@@ -123,13 +123,13 @@
   <p:extLst>
     <p:ext uri="{521415D9-36F7-43E2-AB2F-B90AF26B5E84}">
       <p14:sectionLst xmlns:p14="http://schemas.microsoft.com/office/powerpoint/2010/main">
-        <p14:section name="Introduction" id="{687d534e-d168-4540-a55b-2f84193309ba}">
+        <p14:section name="Introduction" id="{c920cf9e-9ffd-31c6-34cc-4374d502724b}">
           <p14:sldIdLst>
             <p14:sldId id="256"/>
             <p14:sldId id="257"/>
           </p14:sldIdLst>
         </p14:section>
-        <p14:section name="Services" id="{ce9bf24c-9665-dd69-af2d-4d918050c93c}">
+        <p14:section name="Services" id="{c2a68f52-51a9-b290-819c-5e5495e9aee5}">
           <p14:sldIdLst>
             <p14:sldId id="258"/>
             <p14:sldId id="259"/>
@@ -142,19 +142,19 @@
             <p14:sldId id="266"/>
           </p14:sldIdLst>
         </p14:section>
-        <p14:section name="Portfolio" id="{fdf041f5-84c7-00ce-2fdb-676e27becbc5}">
+        <p14:section name="Portfolio" id="{7b5d4770-9296-79fd-24a6-186a0c1bf9b3}">
           <p14:sldIdLst>
             <p14:sldId id="267"/>
             <p14:sldId id="268"/>
           </p14:sldIdLst>
         </p14:section>
-        <p14:section name="Industries &amp; products" id="{bd59a0d3-9881-0885-f425-b4cf99e82bbe}">
+        <p14:section name="Industries &amp; products" id="{4818b3e3-6220-863e-384e-87823f4be7dd}">
           <p14:sldIdLst>
             <p14:sldId id="269"/>
             <p14:sldId id="270"/>
           </p14:sldIdLst>
         </p14:section>
-        <p14:section name="Clients &amp; contact" id="{dc37a638-a47f-1d23-ea44-77511b511aab}">
+        <p14:section name="Clients &amp; contact" id="{d8fe13dc-6e63-51c9-9a75-6d489d2cc6b7}">
           <p14:sldIdLst>
             <p14:sldId id="271"/>
             <p14:sldId id="272"/>
@@ -3393,7 +3393,7 @@
       </p:sp>
       <p:pic>
         <p:nvPicPr>
-          <p:cNvPr id="12" name="Cover scan" descr="C:\Users\ADMIN\Desktop\TEMP\VSHARK_Website\collateral\assets\scan01.jpg">    </p:cNvPr>
+          <p:cNvPr id="12" name="Cover scan" descr="C:\Users\ADMIN\Desktop\TEMP\VSHARK_Website\collateral\assets\cylinder-head-scan.jpg">    </p:cNvPr>
           <p:cNvPicPr>
             <a:picLocks noChangeAspect="1"/>
           </p:cNvPicPr>
@@ -3416,7 +3416,7 @@
       </p:pic>
       <p:pic>
         <p:nvPicPr>
-          <p:cNvPr id="13" name="Cover CAD" descr="C:\Users\ADMIN\Desktop\TEMP\VSHARK_Website\collateral\assets\cad1-cylinder.jpg">    </p:cNvPr>
+          <p:cNvPr id="13" name="Cover CAD" descr="C:\Users\ADMIN\Desktop\TEMP\VSHARK_Website\collateral\assets\cylinder-head-cad.jpg">    </p:cNvPr>
           <p:cNvPicPr>
             <a:picLocks noChangeAspect="1"/>
           </p:cNvPicPr>
@@ -3982,7 +3982,7 @@
                 <a:ea typeface="Century Gothic" pitchFamily="34" charset="-122"/>
                 <a:cs typeface="Century Gothic" pitchFamily="34" charset="-120"/>
               </a:rPr>
-              <a:t>Functional materials</a:t>
+              <a:t>FDM and SLA printing</a:t>
             </a:r>
             <a:endParaRPr lang="en-US" sz="1250" dirty="0"/>
           </a:p>
@@ -4018,7 +4018,7 @@
                   <a:schemeClr val="accent3"/>
                 </a:solidFill>
               </a:rPr>
-              <a:t>Engineering plastics and resins chosen for strength, heat or detail.</a:t>
+              <a:t>FDM engineering plastics for strong parts, SLA resins for fine detail.</a:t>
             </a:r>
             <a:endParaRPr lang="en-US" sz="1050" dirty="0"/>
           </a:p>
@@ -6099,7 +6099,7 @@
       </p:sp>
       <p:pic>
         <p:nvPicPr>
-          <p:cNvPr id="6" name="Cylinder Head scan" descr="C:\Users\ADMIN\Desktop\TEMP\VSHARK_Website\collateral\assets\scan01.jpg">    </p:cNvPr>
+          <p:cNvPr id="6" name="Engine Cylinder Head scan" descr="C:\Users\ADMIN\Desktop\TEMP\VSHARK_Website\collateral\assets\cylinder-head-scan.jpg">    </p:cNvPr>
           <p:cNvPicPr>
             <a:picLocks noChangeAspect="1"/>
           </p:cNvPicPr>
@@ -6122,7 +6122,7 @@
       </p:pic>
       <p:pic>
         <p:nvPicPr>
-          <p:cNvPr id="7" name="Cylinder Head CAD" descr="C:\Users\ADMIN\Desktop\TEMP\VSHARK_Website\collateral\assets\cad1-cylinder.jpg">    </p:cNvPr>
+          <p:cNvPr id="7" name="Engine Cylinder Head CAD" descr="C:\Users\ADMIN\Desktop\TEMP\VSHARK_Website\collateral\assets\cylinder-head-cad.jpg">    </p:cNvPr>
           <p:cNvPicPr>
             <a:picLocks noChangeAspect="1"/>
           </p:cNvPicPr>
@@ -6296,7 +6296,7 @@
                 <a:ea typeface="Century Gothic" pitchFamily="34" charset="-122"/>
                 <a:cs typeface="Century Gothic" pitchFamily="34" charset="-120"/>
               </a:rPr>
-              <a:t>Cylinder Head  </a:t>
+              <a:t>Engine Cylinder Head  </a:t>
             </a:r>
             <a:pPr indent="0" marL="0">
               <a:buNone/>
@@ -6531,7 +6531,7 @@
       </p:sp>
       <p:pic>
         <p:nvPicPr>
-          <p:cNvPr id="20" name="Bike Frame scan" descr="C:\Users\ADMIN\Desktop\TEMP\VSHARK_Website\collateral\assets\bike-scan.jpg">    </p:cNvPr>
+          <p:cNvPr id="20" name="Motorcycle Frame scan" descr="C:\Users\ADMIN\Desktop\TEMP\VSHARK_Website\collateral\assets\bike-scan.jpg">    </p:cNvPr>
           <p:cNvPicPr>
             <a:picLocks noChangeAspect="1"/>
           </p:cNvPicPr>
@@ -6554,7 +6554,7 @@
       </p:pic>
       <p:pic>
         <p:nvPicPr>
-          <p:cNvPr id="21" name="Bike Frame CAD" descr="C:\Users\ADMIN\Desktop\TEMP\VSHARK_Website\collateral\assets\bike-cad.jpg">    </p:cNvPr>
+          <p:cNvPr id="21" name="Motorcycle Frame CAD" descr="C:\Users\ADMIN\Desktop\TEMP\VSHARK_Website\collateral\assets\bike-cad.jpg">    </p:cNvPr>
           <p:cNvPicPr>
             <a:picLocks noChangeAspect="1"/>
           </p:cNvPicPr>
@@ -6728,7 +6728,7 @@
                 <a:ea typeface="Century Gothic" pitchFamily="34" charset="-122"/>
                 <a:cs typeface="Century Gothic" pitchFamily="34" charset="-120"/>
               </a:rPr>
-              <a:t>Bike Frame  </a:t>
+              <a:t>Motorcycle Frame  </a:t>
             </a:r>
             <a:pPr indent="0" marL="0">
               <a:buNone/>
@@ -7280,7 +7280,7 @@
                   <a:schemeClr val="accent5"/>
                 </a:solidFill>
               </a:rPr>
-              <a:t>Photoreal product visuals — footwear, electronics and props.</a:t>
+              <a:t>Photoreal product visuals: footwear, electronics and props.</a:t>
             </a:r>
             <a:endParaRPr lang="en-US" sz="950" dirty="0"/>
           </a:p>
@@ -7408,7 +7408,7 @@
       </p:sp>
       <p:pic>
         <p:nvPicPr>
-          <p:cNvPr id="14" name="Jewellery rendering" descr="C:\Users\ADMIN\Desktop\TEMP\VSHARK_Website\collateral\assets\rendering5.jpg">    </p:cNvPr>
+          <p:cNvPr id="14" name="Jewellery rendering" descr="C:\Users\ADMIN\Desktop\TEMP\VSHARK_Website\collateral\assets\render-ram-ring.jpg">    </p:cNvPr>
           <p:cNvPicPr>
             <a:picLocks noChangeAspect="1"/>
           </p:cNvPicPr>
@@ -7416,7 +7416,7 @@
         </p:nvPicPr>
         <p:blipFill>
           <a:blip r:embed="rId3"/>
-          <a:srcRect l="8884" r="8884" t="0" b="0"/>
+          <a:srcRect l="0" r="0" t="9483" b="9483"/>
           <a:stretch/>
         </p:blipFill>
         <p:spPr>
@@ -7640,7 +7640,7 @@
                   <a:schemeClr val="accent5"/>
                 </a:solidFill>
               </a:rPr>
-              <a:t>Digitally sculpted busts, figures and characters prepared for high-detail printing.</a:t>
+              <a:t>Figures, reliefs and characters sculpted digitally for high-detail resin printing.</a:t>
             </a:r>
             <a:endParaRPr lang="en-US" sz="950" dirty="0"/>
           </a:p>
@@ -7648,7 +7648,7 @@
       </p:sp>
       <p:pic>
         <p:nvPicPr>
-          <p:cNvPr id="22" name="Exhibition stands" descr="C:\Users\ADMIN\Desktop\TEMP\VSHARK_Website\collateral\assets\rendering1.jpg">    </p:cNvPr>
+          <p:cNvPr id="22" name="Exhibition stands" descr="C:\Users\ADMIN\Desktop\TEMP\VSHARK_Website\collateral\assets\render-exhibition.jpg">    </p:cNvPr>
           <p:cNvPicPr>
             <a:picLocks noChangeAspect="1"/>
           </p:cNvPicPr>
@@ -7656,7 +7656,7 @@
         </p:nvPicPr>
         <p:blipFill>
           <a:blip r:embed="rId5"/>
-          <a:srcRect l="8884" r="8884" t="0" b="0"/>
+          <a:srcRect l="15279" r="15279" t="0" b="0"/>
           <a:stretch/>
         </p:blipFill>
         <p:spPr>
@@ -16735,7 +16735,7 @@
                   <a:schemeClr val="accent6"/>
                 </a:solidFill>
               </a:rPr>
-              <a:t>Native files, drawings and reports in the formats your team uses.</a:t>
+              <a:t>CAD files, drawings and reports in the formats your team uses.</a:t>
             </a:r>
             <a:endParaRPr lang="en-US" sz="1300" dirty="0"/>
           </a:p>
@@ -18731,7 +18731,7 @@
         <p:spPr>
           <a:xfrm>
             <a:off x="8439912" y="5120640"/>
-            <a:ext cx="2165299" cy="274320"/>
+            <a:ext cx="1309421" cy="274320"/>
           </a:xfrm>
           <a:prstGeom prst="roundRect">
             <a:avLst>
@@ -18758,7 +18758,7 @@
         <p:spPr>
           <a:xfrm>
             <a:off x="8439912" y="5120640"/>
-            <a:ext cx="2165299" cy="274320"/>
+            <a:ext cx="1309421" cy="274320"/>
           </a:xfrm>
           <a:prstGeom prst="rect">
             <a:avLst/>
@@ -18779,7 +18779,7 @@
                   <a:schemeClr val="accent6"/>
                 </a:solidFill>
               </a:rPr>
-              <a:t>Native SolidWorks / Creo / NX</a:t>
+              <a:t>Scan data (.STL)</a:t>
             </a:r>
             <a:endParaRPr lang="en-US" sz="1000" dirty="0"/>
           </a:p>
@@ -21003,7 +21003,7 @@
         <p:spPr>
           <a:xfrm>
             <a:off x="8176565" y="5120640"/>
-            <a:ext cx="1967789" cy="274320"/>
+            <a:ext cx="1836115" cy="274320"/>
           </a:xfrm>
           <a:prstGeom prst="roundRect">
             <a:avLst>
@@ -21030,7 +21030,7 @@
         <p:spPr>
           <a:xfrm>
             <a:off x="8176565" y="5120640"/>
-            <a:ext cx="1967789" cy="274320"/>
+            <a:ext cx="1836115" cy="274320"/>
           </a:xfrm>
           <a:prstGeom prst="rect">
             <a:avLst/>
@@ -21051,7 +21051,7 @@
                   <a:schemeClr val="accent6"/>
                 </a:solidFill>
               </a:rPr>
-              <a:t>Native Alias / ICEM models</a:t>
+              <a:t>Surface-analysis reports</a:t>
             </a:r>
             <a:endParaRPr lang="en-US" sz="1000" dirty="0"/>
           </a:p>
@@ -21065,8 +21065,8 @@
         </p:nvSpPr>
         <p:spPr>
           <a:xfrm>
-            <a:off x="5806440" y="5468112"/>
-            <a:ext cx="1836115" cy="274320"/>
+            <a:off x="10085832" y="5120640"/>
+            <a:ext cx="1441094" cy="274320"/>
           </a:xfrm>
           <a:prstGeom prst="roundRect">
             <a:avLst>
@@ -21092,8 +21092,8 @@
         </p:nvSpPr>
         <p:spPr>
           <a:xfrm>
-            <a:off x="5806440" y="5468112"/>
-            <a:ext cx="1836115" cy="274320"/>
+            <a:off x="10085832" y="5120640"/>
+            <a:ext cx="1441094" cy="274320"/>
           </a:xfrm>
           <a:prstGeom prst="rect">
             <a:avLst/>
@@ -21114,7 +21114,7 @@
                   <a:schemeClr val="accent6"/>
                 </a:solidFill>
               </a:rPr>
-              <a:t>Surface-analysis reports</a:t>
+              <a:t>Render-ready model</a:t>
             </a:r>
             <a:endParaRPr lang="en-US" sz="1000" dirty="0"/>
           </a:p>
@@ -21122,76 +21122,13 @@
       </p:sp>
       <p:sp>
         <p:nvSpPr>
-          <p:cNvPr id="25" name="Shape 21"/>
-          <p:cNvSpPr/>
-          <p:nvPr/>
-        </p:nvSpPr>
-        <p:spPr>
-          <a:xfrm>
-            <a:off x="7715707" y="5468112"/>
-            <a:ext cx="1441094" cy="274320"/>
-          </a:xfrm>
-          <a:prstGeom prst="roundRect">
-            <a:avLst>
-              <a:gd name="adj" fmla="val 50000"/>
-            </a:avLst>
-          </a:prstGeom>
-          <a:solidFill>
-            <a:schemeClr val="bg1"/>
-          </a:solidFill>
-          <a:ln w="9525">
-            <a:solidFill>
-              <a:schemeClr val="accent5"/>
-            </a:solidFill>
-            <a:prstDash val="solid"/>
-          </a:ln>
-        </p:spPr>
-      </p:sp>
-      <p:sp>
-        <p:nvSpPr>
-          <p:cNvPr id="26" name="Text 22"/>
-          <p:cNvSpPr txBox="1"/>
-          <p:nvPr/>
-        </p:nvSpPr>
-        <p:spPr>
-          <a:xfrm>
-            <a:off x="7715707" y="5468112"/>
-            <a:ext cx="1441094" cy="274320"/>
-          </a:xfrm>
-          <a:prstGeom prst="rect">
-            <a:avLst/>
-          </a:prstGeom>
-          <a:noFill/>
-          <a:ln/>
-        </p:spPr>
-        <p:txBody>
-          <a:bodyPr wrap="square" lIns="0" tIns="0" rIns="0" bIns="0" rtlCol="0" anchor="ctr"/>
-          <a:lstStyle/>
-          <a:p>
-            <a:pPr algn="ctr" indent="0" marL="0">
-              <a:buNone/>
-            </a:pPr>
-            <a:r>
-              <a:rPr lang="en-US" sz="1000" dirty="0">
-                <a:solidFill>
-                  <a:schemeClr val="accent6"/>
-                </a:solidFill>
-              </a:rPr>
-              <a:t>Render-ready model</a:t>
-            </a:r>
-            <a:endParaRPr lang="en-US" sz="1000" dirty="0"/>
-          </a:p>
-        </p:txBody>
-      </p:sp>
-      <p:sp>
-        <p:nvSpPr>
-          <p:cNvPr id="27" name="Text 23"/>
-          <p:cNvSpPr txBox="1"/>
-          <p:nvPr/>
-        </p:nvSpPr>
-        <p:spPr>
-          <a:xfrm>
-            <a:off x="5806440" y="5852160"/>
+          <p:cNvPr id="25" name="Text 21"/>
+          <p:cNvSpPr txBox="1"/>
+          <p:nvPr/>
+        </p:nvSpPr>
+        <p:spPr>
+          <a:xfrm>
+            <a:off x="5806440" y="5504688"/>
             <a:ext cx="2743200" cy="182880"/>
           </a:xfrm>
           <a:prstGeom prst="rect">
@@ -21224,13 +21161,13 @@
       </p:sp>
       <p:sp>
         <p:nvSpPr>
-          <p:cNvPr id="28" name="Shape 24"/>
+          <p:cNvPr id="26" name="Shape 22"/>
           <p:cNvSpPr/>
           <p:nvPr/>
         </p:nvSpPr>
         <p:spPr>
           <a:xfrm>
-            <a:off x="5806440" y="6080760"/>
+            <a:off x="5806440" y="5733288"/>
             <a:ext cx="914400" cy="274320"/>
           </a:xfrm>
           <a:prstGeom prst="roundRect">
@@ -21251,13 +21188,13 @@
       </p:sp>
       <p:sp>
         <p:nvSpPr>
-          <p:cNvPr id="29" name="Text 25"/>
-          <p:cNvSpPr txBox="1"/>
-          <p:nvPr/>
-        </p:nvSpPr>
-        <p:spPr>
-          <a:xfrm>
-            <a:off x="5806440" y="6080760"/>
+          <p:cNvPr id="27" name="Text 23"/>
+          <p:cNvSpPr txBox="1"/>
+          <p:nvPr/>
+        </p:nvSpPr>
+        <p:spPr>
+          <a:xfrm>
+            <a:off x="5806440" y="5733288"/>
             <a:ext cx="914400" cy="274320"/>
           </a:xfrm>
           <a:prstGeom prst="rect">
@@ -21287,13 +21224,13 @@
       </p:sp>
       <p:sp>
         <p:nvSpPr>
-          <p:cNvPr id="30" name="Shape 26"/>
+          <p:cNvPr id="28" name="Shape 24"/>
           <p:cNvSpPr/>
           <p:nvPr/>
         </p:nvSpPr>
         <p:spPr>
           <a:xfrm>
-            <a:off x="6793992" y="6080760"/>
+            <a:off x="6793992" y="5733288"/>
             <a:ext cx="848563" cy="274320"/>
           </a:xfrm>
           <a:prstGeom prst="roundRect">
@@ -21314,13 +21251,13 @@
       </p:sp>
       <p:sp>
         <p:nvSpPr>
-          <p:cNvPr id="31" name="Text 27"/>
-          <p:cNvSpPr txBox="1"/>
-          <p:nvPr/>
-        </p:nvSpPr>
-        <p:spPr>
-          <a:xfrm>
-            <a:off x="6793992" y="6080760"/>
+          <p:cNvPr id="29" name="Text 25"/>
+          <p:cNvSpPr txBox="1"/>
+          <p:nvPr/>
+        </p:nvSpPr>
+        <p:spPr>
+          <a:xfrm>
+            <a:off x="6793992" y="5733288"/>
             <a:ext cx="848563" cy="274320"/>
           </a:xfrm>
           <a:prstGeom prst="rect">

</xml_diff>

<commit_message>
Collateral: new image crops, scanner-precision wording, confirmed facts
- Service slides: 4:3 image with deliverables and industries below it
- Tiles use the 16:10 crops, deck industry cards the portrait crops,
  brochure industry cards the square crops
- '0.02 mm scanner precision (up to)' instead of 'scan accuracy' (A13);
  7 countries served; scanners: installation, training, 12-month warranty

Co-Authored-By: Claude Opus 5.5 <noreply@anthropic.com>
</commit_message>
<xml_diff>
--- a/collateral/VShark-Presentation.pptx
+++ b/collateral/VShark-Presentation.pptx
@@ -123,13 +123,13 @@
   <p:extLst>
     <p:ext uri="{521415D9-36F7-43E2-AB2F-B90AF26B5E84}">
       <p14:sectionLst xmlns:p14="http://schemas.microsoft.com/office/powerpoint/2010/main">
-        <p14:section name="Introduction" id="{c920cf9e-9ffd-31c6-34cc-4374d502724b}">
+        <p14:section name="Introduction" id="{c00043f8-1041-fddd-42d6-cbeae92b8166}">
           <p14:sldIdLst>
             <p14:sldId id="256"/>
             <p14:sldId id="257"/>
           </p14:sldIdLst>
         </p14:section>
-        <p14:section name="Services" id="{c2a68f52-51a9-b290-819c-5e5495e9aee5}">
+        <p14:section name="Services" id="{e1707035-784d-6ab9-d43c-f8f0b444c795}">
           <p14:sldIdLst>
             <p14:sldId id="258"/>
             <p14:sldId id="259"/>
@@ -142,19 +142,19 @@
             <p14:sldId id="266"/>
           </p14:sldIdLst>
         </p14:section>
-        <p14:section name="Portfolio" id="{7b5d4770-9296-79fd-24a6-186a0c1bf9b3}">
+        <p14:section name="Portfolio" id="{dd6fcbd6-6d85-231c-e618-ffc29640bdbc}">
           <p14:sldIdLst>
             <p14:sldId id="267"/>
             <p14:sldId id="268"/>
           </p14:sldIdLst>
         </p14:section>
-        <p14:section name="Industries &amp; products" id="{4818b3e3-6220-863e-384e-87823f4be7dd}">
+        <p14:section name="Industries &amp; products" id="{5e568033-0814-d0d2-cddf-7bd885ea9fb1}">
           <p14:sldIdLst>
             <p14:sldId id="269"/>
             <p14:sldId id="270"/>
           </p14:sldIdLst>
         </p14:section>
-        <p14:section name="Clients &amp; contact" id="{d8fe13dc-6e63-51c9-9a75-6d489d2cc6b7}">
+        <p14:section name="Clients &amp; contact" id="{7a56c259-cbb5-cc50-4fc9-7f11f2ed8ad4}">
           <p14:sldIdLst>
             <p14:sldId id="271"/>
             <p14:sldId id="272"/>
@@ -1180,7 +1180,7 @@
           <a:p>
             <a:r>
               <a:rPr lang="en-US" dirty="0"/>
-              <a:t>Clients in US · UK · Germany · Canada · UAE · Saudi Arabia.</a:t>
+              <a:t>Clients in India · UAE · Saudi Arabia · USA · UK · Germany · Canada.</a:t>
             </a:r>
             <a:endParaRPr lang="en-US" dirty="0"/>
           </a:p>
@@ -3714,7 +3714,7 @@
       </p:sp>
       <p:pic>
         <p:nvPicPr>
-          <p:cNvPr id="5" name="3D Printing" descr="C:\Users\ADMIN\Desktop\TEMP\VSHARK_Website\collateral\assets\printing.jpg">    </p:cNvPr>
+          <p:cNvPr id="5" name="3D Printing" descr="C:\Users\ADMIN\Desktop\TEMP\VSHARK_Website\collateral\assets\resin-3d-printed-prototype-of-an-engine-crankcase-beside-the-original-casting-4x3.jpg">    </p:cNvPr>
           <p:cNvPicPr>
             <a:picLocks noChangeAspect="1"/>
           </p:cNvPicPr>
@@ -3722,13 +3722,13 @@
         </p:nvPicPr>
         <p:blipFill>
           <a:blip r:embed="rId1"/>
-          <a:srcRect l="6911" r="6911" t="0" b="0"/>
+          <a:srcRect l="0" r="0" t="0" b="0"/>
           <a:stretch/>
         </p:blipFill>
         <p:spPr>
           <a:xfrm>
             <a:off x="609905" y="548640"/>
-            <a:ext cx="4846320" cy="5623560"/>
+            <a:ext cx="4846320" cy="3634740"/>
           </a:xfrm>
           <a:prstGeom prst="rect">
             <a:avLst/>
@@ -3743,7 +3743,7 @@
         </p:nvSpPr>
         <p:spPr>
           <a:xfrm>
-            <a:off x="774497" y="5760720"/>
+            <a:off x="774497" y="3813048"/>
             <a:ext cx="1211580" cy="237744"/>
           </a:xfrm>
           <a:prstGeom prst="rect">
@@ -3765,7 +3765,7 @@
         </p:nvSpPr>
         <p:spPr>
           <a:xfrm>
-            <a:off x="774497" y="5760720"/>
+            <a:off x="774497" y="3813048"/>
             <a:ext cx="1211580" cy="237744"/>
           </a:xfrm>
           <a:prstGeom prst="rect">
@@ -4182,7 +4182,7 @@
         </p:nvSpPr>
         <p:spPr>
           <a:xfrm>
-            <a:off x="5806440" y="4892040"/>
+            <a:off x="609905" y="4389120"/>
             <a:ext cx="2743200" cy="182880"/>
           </a:xfrm>
           <a:prstGeom prst="rect">
@@ -4221,7 +4221,7 @@
         </p:nvSpPr>
         <p:spPr>
           <a:xfrm>
-            <a:off x="5806440" y="5120640"/>
+            <a:off x="609905" y="4617720"/>
             <a:ext cx="1111910" cy="274320"/>
           </a:xfrm>
           <a:prstGeom prst="roundRect">
@@ -4248,7 +4248,7 @@
         </p:nvSpPr>
         <p:spPr>
           <a:xfrm>
-            <a:off x="5806440" y="5120640"/>
+            <a:off x="609905" y="4617720"/>
             <a:ext cx="1111910" cy="274320"/>
           </a:xfrm>
           <a:prstGeom prst="rect">
@@ -4284,7 +4284,7 @@
         </p:nvSpPr>
         <p:spPr>
           <a:xfrm>
-            <a:off x="6991502" y="5120640"/>
+            <a:off x="1794967" y="4617720"/>
             <a:ext cx="2231136" cy="274320"/>
           </a:xfrm>
           <a:prstGeom prst="roundRect">
@@ -4311,7 +4311,7 @@
         </p:nvSpPr>
         <p:spPr>
           <a:xfrm>
-            <a:off x="6991502" y="5120640"/>
+            <a:off x="1794967" y="4617720"/>
             <a:ext cx="2231136" cy="274320"/>
           </a:xfrm>
           <a:prstGeom prst="rect">
@@ -4347,7 +4347,7 @@
         </p:nvSpPr>
         <p:spPr>
           <a:xfrm>
-            <a:off x="5806440" y="5468112"/>
+            <a:off x="609905" y="4965192"/>
             <a:ext cx="2296973" cy="274320"/>
           </a:xfrm>
           <a:prstGeom prst="roundRect">
@@ -4374,7 +4374,7 @@
         </p:nvSpPr>
         <p:spPr>
           <a:xfrm>
-            <a:off x="5806440" y="5468112"/>
+            <a:off x="609905" y="4965192"/>
             <a:ext cx="2296973" cy="274320"/>
           </a:xfrm>
           <a:prstGeom prst="rect">
@@ -4410,7 +4410,7 @@
         </p:nvSpPr>
         <p:spPr>
           <a:xfrm>
-            <a:off x="8176565" y="5468112"/>
+            <a:off x="2980030" y="4965192"/>
             <a:ext cx="1836115" cy="274320"/>
           </a:xfrm>
           <a:prstGeom prst="roundRect">
@@ -4437,7 +4437,7 @@
         </p:nvSpPr>
         <p:spPr>
           <a:xfrm>
-            <a:off x="8176565" y="5468112"/>
+            <a:off x="2980030" y="4965192"/>
             <a:ext cx="1836115" cy="274320"/>
           </a:xfrm>
           <a:prstGeom prst="rect">
@@ -4473,7 +4473,7 @@
         </p:nvSpPr>
         <p:spPr>
           <a:xfrm>
-            <a:off x="5806440" y="5852160"/>
+            <a:off x="609905" y="5367528"/>
             <a:ext cx="2743200" cy="182880"/>
           </a:xfrm>
           <a:prstGeom prst="rect">
@@ -4512,7 +4512,7 @@
         </p:nvSpPr>
         <p:spPr>
           <a:xfrm>
-            <a:off x="5806440" y="6080760"/>
+            <a:off x="609905" y="5596128"/>
             <a:ext cx="848563" cy="274320"/>
           </a:xfrm>
           <a:prstGeom prst="roundRect">
@@ -4539,7 +4539,7 @@
         </p:nvSpPr>
         <p:spPr>
           <a:xfrm>
-            <a:off x="5806440" y="6080760"/>
+            <a:off x="609905" y="5596128"/>
             <a:ext cx="848563" cy="274320"/>
           </a:xfrm>
           <a:prstGeom prst="rect">
@@ -4575,7 +4575,7 @@
         </p:nvSpPr>
         <p:spPr>
           <a:xfrm>
-            <a:off x="6728155" y="6080760"/>
+            <a:off x="1531620" y="5596128"/>
             <a:ext cx="914400" cy="274320"/>
           </a:xfrm>
           <a:prstGeom prst="roundRect">
@@ -4602,7 +4602,7 @@
         </p:nvSpPr>
         <p:spPr>
           <a:xfrm>
-            <a:off x="6728155" y="6080760"/>
+            <a:off x="1531620" y="5596128"/>
             <a:ext cx="914400" cy="274320"/>
           </a:xfrm>
           <a:prstGeom prst="rect">
@@ -4638,7 +4638,7 @@
         </p:nvSpPr>
         <p:spPr>
           <a:xfrm>
-            <a:off x="7715707" y="6080760"/>
+            <a:off x="2519172" y="5596128"/>
             <a:ext cx="848563" cy="274320"/>
           </a:xfrm>
           <a:prstGeom prst="roundRect">
@@ -4665,7 +4665,7 @@
         </p:nvSpPr>
         <p:spPr>
           <a:xfrm>
-            <a:off x="7715707" y="6080760"/>
+            <a:off x="2519172" y="5596128"/>
             <a:ext cx="848563" cy="274320"/>
           </a:xfrm>
           <a:prstGeom prst="rect">
@@ -4701,7 +4701,7 @@
         </p:nvSpPr>
         <p:spPr>
           <a:xfrm>
-            <a:off x="8637422" y="6080760"/>
+            <a:off x="3440887" y="5596128"/>
             <a:ext cx="914400" cy="274320"/>
           </a:xfrm>
           <a:prstGeom prst="roundRect">
@@ -4728,7 +4728,7 @@
         </p:nvSpPr>
         <p:spPr>
           <a:xfrm>
-            <a:off x="8637422" y="6080760"/>
+            <a:off x="3440887" y="5596128"/>
             <a:ext cx="914400" cy="274320"/>
           </a:xfrm>
           <a:prstGeom prst="rect">
@@ -4913,7 +4913,7 @@
       </p:sp>
       <p:pic>
         <p:nvPicPr>
-          <p:cNvPr id="5" name="Product Rendering" descr="C:\Users\ADMIN\Desktop\TEMP\VSHARK_Website\collateral\assets\product-rendering.jpg">    </p:cNvPr>
+          <p:cNvPr id="5" name="Product Rendering" descr="C:\Users\ADMIN\Desktop\TEMP\VSHARK_Website\collateral\assets\product-rendering-of-wireless-earbuds-from-clay-model-to-photorealistic-render-4x3.jpg">    </p:cNvPr>
           <p:cNvPicPr>
             <a:picLocks noChangeAspect="1"/>
           </p:cNvPicPr>
@@ -4921,13 +4921,13 @@
         </p:nvPicPr>
         <p:blipFill>
           <a:blip r:embed="rId1"/>
-          <a:srcRect l="6911" r="6911" t="0" b="0"/>
+          <a:srcRect l="0" r="0" t="0" b="0"/>
           <a:stretch/>
         </p:blipFill>
         <p:spPr>
           <a:xfrm>
             <a:off x="609905" y="548640"/>
-            <a:ext cx="4846320" cy="5623560"/>
+            <a:ext cx="4846320" cy="3634740"/>
           </a:xfrm>
           <a:prstGeom prst="rect">
             <a:avLst/>
@@ -4942,7 +4942,7 @@
         </p:nvSpPr>
         <p:spPr>
           <a:xfrm>
-            <a:off x="774497" y="5760720"/>
+            <a:off x="774497" y="3813048"/>
             <a:ext cx="1211580" cy="237744"/>
           </a:xfrm>
           <a:prstGeom prst="rect">
@@ -4964,7 +4964,7 @@
         </p:nvSpPr>
         <p:spPr>
           <a:xfrm>
-            <a:off x="774497" y="5760720"/>
+            <a:off x="774497" y="3813048"/>
             <a:ext cx="1211580" cy="237744"/>
           </a:xfrm>
           <a:prstGeom prst="rect">
@@ -5381,7 +5381,7 @@
         </p:nvSpPr>
         <p:spPr>
           <a:xfrm>
-            <a:off x="5806440" y="4892040"/>
+            <a:off x="609905" y="4389120"/>
             <a:ext cx="2743200" cy="182880"/>
           </a:xfrm>
           <a:prstGeom prst="rect">
@@ -5420,7 +5420,7 @@
         </p:nvSpPr>
         <p:spPr>
           <a:xfrm>
-            <a:off x="5806440" y="5120640"/>
+            <a:off x="609905" y="4617720"/>
             <a:ext cx="2165299" cy="274320"/>
           </a:xfrm>
           <a:prstGeom prst="roundRect">
@@ -5447,7 +5447,7 @@
         </p:nvSpPr>
         <p:spPr>
           <a:xfrm>
-            <a:off x="5806440" y="5120640"/>
+            <a:off x="609905" y="4617720"/>
             <a:ext cx="2165299" cy="274320"/>
           </a:xfrm>
           <a:prstGeom prst="rect">
@@ -5483,7 +5483,7 @@
         </p:nvSpPr>
         <p:spPr>
           <a:xfrm>
-            <a:off x="8044891" y="5120640"/>
+            <a:off x="2848356" y="4617720"/>
             <a:ext cx="1375258" cy="274320"/>
           </a:xfrm>
           <a:prstGeom prst="roundRect">
@@ -5510,7 +5510,7 @@
         </p:nvSpPr>
         <p:spPr>
           <a:xfrm>
-            <a:off x="8044891" y="5120640"/>
+            <a:off x="2848356" y="4617720"/>
             <a:ext cx="1375258" cy="274320"/>
           </a:xfrm>
           <a:prstGeom prst="rect">
@@ -5546,7 +5546,7 @@
         </p:nvSpPr>
         <p:spPr>
           <a:xfrm>
-            <a:off x="9493301" y="5120640"/>
+            <a:off x="609905" y="4965192"/>
             <a:ext cx="1243584" cy="274320"/>
           </a:xfrm>
           <a:prstGeom prst="roundRect">
@@ -5573,7 +5573,7 @@
         </p:nvSpPr>
         <p:spPr>
           <a:xfrm>
-            <a:off x="9493301" y="5120640"/>
+            <a:off x="609905" y="4965192"/>
             <a:ext cx="1243584" cy="274320"/>
           </a:xfrm>
           <a:prstGeom prst="rect">
@@ -5609,7 +5609,7 @@
         </p:nvSpPr>
         <p:spPr>
           <a:xfrm>
-            <a:off x="5806440" y="5468112"/>
+            <a:off x="1926641" y="4965192"/>
             <a:ext cx="1572768" cy="274320"/>
           </a:xfrm>
           <a:prstGeom prst="roundRect">
@@ -5636,7 +5636,7 @@
         </p:nvSpPr>
         <p:spPr>
           <a:xfrm>
-            <a:off x="5806440" y="5468112"/>
+            <a:off x="1926641" y="4965192"/>
             <a:ext cx="1572768" cy="274320"/>
           </a:xfrm>
           <a:prstGeom prst="rect">
@@ -5672,7 +5672,7 @@
         </p:nvSpPr>
         <p:spPr>
           <a:xfrm>
-            <a:off x="5806440" y="5852160"/>
+            <a:off x="609905" y="5367528"/>
             <a:ext cx="2743200" cy="182880"/>
           </a:xfrm>
           <a:prstGeom prst="rect">
@@ -5711,7 +5711,7 @@
         </p:nvSpPr>
         <p:spPr>
           <a:xfrm>
-            <a:off x="5806440" y="6080760"/>
+            <a:off x="609905" y="5596128"/>
             <a:ext cx="848563" cy="274320"/>
           </a:xfrm>
           <a:prstGeom prst="roundRect">
@@ -5738,7 +5738,7 @@
         </p:nvSpPr>
         <p:spPr>
           <a:xfrm>
-            <a:off x="5806440" y="6080760"/>
+            <a:off x="609905" y="5596128"/>
             <a:ext cx="848563" cy="274320"/>
           </a:xfrm>
           <a:prstGeom prst="rect">
@@ -5774,7 +5774,7 @@
         </p:nvSpPr>
         <p:spPr>
           <a:xfrm>
-            <a:off x="6728155" y="6080760"/>
+            <a:off x="1531620" y="5596128"/>
             <a:ext cx="1046074" cy="274320"/>
           </a:xfrm>
           <a:prstGeom prst="roundRect">
@@ -5801,7 +5801,7 @@
         </p:nvSpPr>
         <p:spPr>
           <a:xfrm>
-            <a:off x="6728155" y="6080760"/>
+            <a:off x="1531620" y="5596128"/>
             <a:ext cx="1046074" cy="274320"/>
           </a:xfrm>
           <a:prstGeom prst="rect">
@@ -5837,7 +5837,7 @@
         </p:nvSpPr>
         <p:spPr>
           <a:xfrm>
-            <a:off x="7847381" y="6080760"/>
+            <a:off x="2650846" y="5596128"/>
             <a:ext cx="914400" cy="274320"/>
           </a:xfrm>
           <a:prstGeom prst="roundRect">
@@ -5864,7 +5864,7 @@
         </p:nvSpPr>
         <p:spPr>
           <a:xfrm>
-            <a:off x="7847381" y="6080760"/>
+            <a:off x="2650846" y="5596128"/>
             <a:ext cx="914400" cy="274320"/>
           </a:xfrm>
           <a:prstGeom prst="rect">
@@ -7280,7 +7280,7 @@
                   <a:schemeClr val="accent5"/>
                 </a:solidFill>
               </a:rPr>
-              <a:t>Photoreal product visuals: footwear, electronics and props.</a:t>
+              <a:t>Photoreal product visuals: electronics, tools and props.</a:t>
             </a:r>
             <a:endParaRPr lang="en-US" sz="950" dirty="0"/>
           </a:p>
@@ -7640,7 +7640,7 @@
                   <a:schemeClr val="accent5"/>
                 </a:solidFill>
               </a:rPr>
-              <a:t>Figures, reliefs and characters sculpted digitally for high-detail resin printing.</a:t>
+              <a:t>Figures, reliefs and creatures sculpted digitally for high-detail resin printing.</a:t>
             </a:r>
             <a:endParaRPr lang="en-US" sz="950" dirty="0"/>
           </a:p>
@@ -7973,7 +7973,7 @@
       </p:sp>
       <p:pic>
         <p:nvPicPr>
-          <p:cNvPr id="6" name="Aerospace" descr="C:\Users\ADMIN\Desktop\TEMP\VSHARK_Website\collateral\assets\aerospace.jpg">    </p:cNvPr>
+          <p:cNvPr id="6" name="Aerospace" descr="C:\Users\ADMIN\Desktop\TEMP\VSHARK_Website\collateral\assets\3d-laser-scanning-of-a-jet-engine-fan-blade-in-an-aircraft-hangar-4x5.jpg">    </p:cNvPr>
           <p:cNvPicPr>
             <a:picLocks noChangeAspect="1"/>
           </p:cNvPicPr>
@@ -7981,7 +7981,7 @@
         </p:nvPicPr>
         <p:blipFill>
           <a:blip r:embed="rId1"/>
-          <a:srcRect l="27446" r="27446" t="0" b="0"/>
+          <a:srcRect l="25331" r="25331" t="0" b="0"/>
           <a:stretch/>
         </p:blipFill>
         <p:spPr>
@@ -8132,7 +8132,7 @@
       </p:sp>
       <p:pic>
         <p:nvPicPr>
-          <p:cNvPr id="11" name="Automobile" descr="C:\Users\ADMIN\Desktop\TEMP\VSHARK_Website\collateral\assets\auto.jpg">    </p:cNvPr>
+          <p:cNvPr id="11" name="Automobile" descr="C:\Users\ADMIN\Desktop\TEMP\VSHARK_Website\collateral\assets\handheld-3d-scanning-of-a-cast-aluminium-engine-block-4x5.jpg">    </p:cNvPr>
           <p:cNvPicPr>
             <a:picLocks noChangeAspect="1"/>
           </p:cNvPicPr>
@@ -8140,7 +8140,7 @@
         </p:nvPicPr>
         <p:blipFill>
           <a:blip r:embed="rId2"/>
-          <a:srcRect l="27446" r="27446" t="0" b="0"/>
+          <a:srcRect l="25331" r="25331" t="0" b="0"/>
           <a:stretch/>
         </p:blipFill>
         <p:spPr>
@@ -8291,7 +8291,7 @@
       </p:sp>
       <p:pic>
         <p:nvPicPr>
-          <p:cNvPr id="16" name="Construction" descr="C:\Users\ADMIN\Desktop\TEMP\VSHARK_Website\collateral\assets\construction.jpg">    </p:cNvPr>
+          <p:cNvPr id="16" name="Construction" descr="C:\Users\ADMIN\Desktop\TEMP\VSHARK_Website\collateral\assets\terrestrial-laser-scanning-of-a-building-under-renovation-for-scan-to-bim-4x5.jpg">    </p:cNvPr>
           <p:cNvPicPr>
             <a:picLocks noChangeAspect="1"/>
           </p:cNvPicPr>
@@ -8299,7 +8299,7 @@
         </p:nvPicPr>
         <p:blipFill>
           <a:blip r:embed="rId3"/>
-          <a:srcRect l="27446" r="27446" t="0" b="0"/>
+          <a:srcRect l="25331" r="25331" t="0" b="0"/>
           <a:stretch/>
         </p:blipFill>
         <p:spPr>
@@ -8450,7 +8450,7 @@
       </p:sp>
       <p:pic>
         <p:nvPicPr>
-          <p:cNvPr id="21" name="Healthcare" descr="C:\Users\ADMIN\Desktop\TEMP\VSHARK_Website\collateral\assets\hospital.jpg">    </p:cNvPr>
+          <p:cNvPr id="21" name="Healthcare" descr="C:\Users\ADMIN\Desktop\TEMP\VSHARK_Website\collateral\assets\3d-scanning-a-leg-cast-to-make-a-custom-3d-printed-orthotic-brace-4x5.jpg">    </p:cNvPr>
           <p:cNvPicPr>
             <a:picLocks noChangeAspect="1"/>
           </p:cNvPicPr>
@@ -8458,7 +8458,7 @@
         </p:nvPicPr>
         <p:blipFill>
           <a:blip r:embed="rId4"/>
-          <a:srcRect l="27446" r="27446" t="0" b="0"/>
+          <a:srcRect l="25331" r="25331" t="0" b="0"/>
           <a:stretch/>
         </p:blipFill>
         <p:spPr>
@@ -8609,7 +8609,7 @@
       </p:sp>
       <p:pic>
         <p:nvPicPr>
-          <p:cNvPr id="26" name="Education" descr="C:\Users\ADMIN\Desktop\TEMP\VSHARK_Website\collateral\assets\institute.jpg">    </p:cNvPr>
+          <p:cNvPr id="26" name="Education" descr="C:\Users\ADMIN\Desktop\TEMP\VSHARK_Website\collateral\assets\engineering-students-3d-scanning-a-gear-with-a-handheld-3d-scanner-4x5.jpg">    </p:cNvPr>
           <p:cNvPicPr>
             <a:picLocks noChangeAspect="1"/>
           </p:cNvPicPr>
@@ -8617,7 +8617,7 @@
         </p:nvPicPr>
         <p:blipFill>
           <a:blip r:embed="rId5"/>
-          <a:srcRect l="27446" r="27446" t="0" b="0"/>
+          <a:srcRect l="25331" r="25331" t="0" b="0"/>
           <a:stretch/>
         </p:blipFill>
         <p:spPr>
@@ -8768,7 +8768,7 @@
       </p:sp>
       <p:pic>
         <p:nvPicPr>
-          <p:cNvPr id="31" name="Jewellery" descr="C:\Users\ADMIN\Desktop\TEMP\VSHARK_Website\collateral\assets\jewelery.jpg">    </p:cNvPr>
+          <p:cNvPr id="31" name="Jewellery" descr="C:\Users\ADMIN\Desktop\TEMP\VSHARK_Website\collateral\assets\gold-temple-pendant-beside-its-3d-printed-resin-casting-pattern-4x5.jpg">    </p:cNvPr>
           <p:cNvPicPr>
             <a:picLocks noChangeAspect="1"/>
           </p:cNvPicPr>
@@ -8776,7 +8776,7 @@
         </p:nvPicPr>
         <p:blipFill>
           <a:blip r:embed="rId6"/>
-          <a:srcRect l="27446" r="27446" t="0" b="0"/>
+          <a:srcRect l="25331" r="25331" t="0" b="0"/>
           <a:stretch/>
         </p:blipFill>
         <p:spPr>
@@ -12047,7 +12047,7 @@
                 <a:ea typeface="Consolas" pitchFamily="34" charset="-122"/>
                 <a:cs typeface="Consolas" pitchFamily="34" charset="-120"/>
               </a:rPr>
-              <a:t>US · UK · GERMANY · CANADA · UAE · SAUDI ARABIA</a:t>
+              <a:t>INDIA · UAE · SAUDI ARABIA · USA · UK · GERMANY · CANADA</a:t>
             </a:r>
             <a:endParaRPr lang="en-US" sz="1100" dirty="0"/>
           </a:p>
@@ -14122,7 +14122,7 @@
       </p:sp>
       <p:sp>
         <p:nvSpPr>
-          <p:cNvPr id="6" name="Stat Scan accuracy"/>
+          <p:cNvPr id="6" name="Stat Scanner precision (up to)"/>
           <p:cNvSpPr/>
           <p:nvPr/>
         </p:nvSpPr>
@@ -14233,7 +14233,7 @@
                 <a:ea typeface="Consolas" pitchFamily="34" charset="-122"/>
                 <a:cs typeface="Consolas" pitchFamily="34" charset="-120"/>
               </a:rPr>
-              <a:t>SCAN ACCURACY</a:t>
+              <a:t>SCANNER PRECISION (UP TO)</a:t>
             </a:r>
             <a:endParaRPr lang="en-US" sz="1000" dirty="0"/>
           </a:p>
@@ -14457,7 +14457,7 @@
       </p:sp>
       <p:sp>
         <p:nvSpPr>
-          <p:cNvPr id="15" name="Stat Countries with repeat clients"/>
+          <p:cNvPr id="15" name="Stat Countries served"/>
           <p:cNvSpPr/>
           <p:nvPr/>
         </p:nvSpPr>
@@ -14515,22 +14515,11 @@
                 <a:ea typeface="Century Gothic" pitchFamily="34" charset="-122"/>
                 <a:cs typeface="Century Gothic" pitchFamily="34" charset="-120"/>
               </a:rPr>
-              <a:t>6</a:t>
-            </a:r>
-            <a:pPr indent="0" marL="0">
-              <a:buNone/>
-            </a:pPr>
-            <a:r>
-              <a:rPr lang="en-US" sz="2000" dirty="0">
-                <a:solidFill>
-                  <a:schemeClr val="accent1"/>
-                </a:solidFill>
-                <a:latin typeface="Century Gothic" pitchFamily="34" charset="0"/>
-                <a:ea typeface="Century Gothic" pitchFamily="34" charset="-122"/>
-                <a:cs typeface="Century Gothic" pitchFamily="34" charset="-120"/>
-              </a:rPr>
-              <a:t>+</a:t>
-            </a:r>
+              <a:t>7</a:t>
+            </a:r>
+            <a:pPr indent="0" marL="0">
+              <a:buNone/>
+            </a:pPr>
             <a:endParaRPr lang="en-US" sz="4400" dirty="0"/>
           </a:p>
         </p:txBody>
@@ -14568,7 +14557,7 @@
                 <a:ea typeface="Consolas" pitchFamily="34" charset="-122"/>
                 <a:cs typeface="Consolas" pitchFamily="34" charset="-120"/>
               </a:rPr>
-              <a:t>COUNTRIES WITH REPEAT CLIENTS</a:t>
+              <a:t>COUNTRIES SERVED</a:t>
             </a:r>
             <a:endParaRPr lang="en-US" sz="1000" dirty="0"/>
           </a:p>
@@ -14808,7 +14797,7 @@
       </p:sp>
       <p:pic>
         <p:nvPicPr>
-          <p:cNvPr id="7" name="3D Scanning" descr="C:\Users\ADMIN\Desktop\TEMP\VSHARK_Website\collateral\assets\01-scanning.jpg">    </p:cNvPr>
+          <p:cNvPr id="7" name="3D Scanning" descr="C:\Users\ADMIN\Desktop\TEMP\VSHARK_Website\collateral\assets\handheld-3d-laser-scanning-of-an-engine-cylinder-head-16x10.jpg">    </p:cNvPr>
           <p:cNvPicPr>
             <a:picLocks noChangeAspect="1"/>
           </p:cNvPicPr>
@@ -14816,7 +14805,7 @@
         </p:nvPicPr>
         <p:blipFill>
           <a:blip r:embed="rId1"/>
-          <a:srcRect l="0" r="0" t="31577" b="31577"/>
+          <a:srcRect l="0" r="0" t="20545" b="20545"/>
           <a:stretch/>
         </p:blipFill>
         <p:spPr>
@@ -14972,7 +14961,7 @@
       </p:sp>
       <p:pic>
         <p:nvPicPr>
-          <p:cNvPr id="12" name="Reverse Engineering" descr="C:\Users\ADMIN\Desktop\TEMP\VSHARK_Website\collateral\assets\02-reverse-engineering.jpg">    </p:cNvPr>
+          <p:cNvPr id="12" name="Reverse Engineering" descr="C:\Users\ADMIN\Desktop\TEMP\VSHARK_Website\collateral\assets\3d-scan-to-cad-reverse-engineering-of-a-motorcycle-tubular-frame-16x10.jpg">    </p:cNvPr>
           <p:cNvPicPr>
             <a:picLocks noChangeAspect="1"/>
           </p:cNvPicPr>
@@ -14980,7 +14969,7 @@
         </p:nvPicPr>
         <p:blipFill>
           <a:blip r:embed="rId2"/>
-          <a:srcRect l="0" r="0" t="31577" b="31577"/>
+          <a:srcRect l="0" r="0" t="20545" b="20545"/>
           <a:stretch/>
         </p:blipFill>
         <p:spPr>
@@ -15136,7 +15125,7 @@
       </p:sp>
       <p:pic>
         <p:nvPicPr>
-          <p:cNvPr id="17" name="Scan to BIM" descr="C:\Users\ADMIN\Desktop\TEMP\VSHARK_Website\collateral\assets\bim.jpg">    </p:cNvPr>
+          <p:cNvPr id="17" name="Scan to BIM" descr="C:\Users\ADMIN\Desktop\TEMP\VSHARK_Website\collateral\assets\terrestrial-laser-scanning-of-an-industrial-pump-room-for-scan-to-bim-16x10.jpg">    </p:cNvPr>
           <p:cNvPicPr>
             <a:picLocks noChangeAspect="1"/>
           </p:cNvPicPr>
@@ -15144,7 +15133,7 @@
         </p:nvPicPr>
         <p:blipFill>
           <a:blip r:embed="rId3"/>
-          <a:srcRect l="0" r="0" t="31577" b="31577"/>
+          <a:srcRect l="0" r="0" t="20545" b="20545"/>
           <a:stretch/>
         </p:blipFill>
         <p:spPr>
@@ -15300,7 +15289,7 @@
       </p:sp>
       <p:pic>
         <p:nvPicPr>
-          <p:cNvPr id="22" name="Class A Surfacing" descr="C:\Users\ADMIN\Desktop\TEMP\VSHARK_Website\collateral\assets\class-a.jpg">    </p:cNvPr>
+          <p:cNvPr id="22" name="Class A Surfacing" descr="C:\Users\ADMIN\Desktop\TEMP\VSHARK_Website\collateral\assets\class-a-surface-zebra-stripe-analysis-of-a-car-fender-16x10.jpg">    </p:cNvPr>
           <p:cNvPicPr>
             <a:picLocks noChangeAspect="1"/>
           </p:cNvPicPr>
@@ -15308,7 +15297,7 @@
         </p:nvPicPr>
         <p:blipFill>
           <a:blip r:embed="rId4"/>
-          <a:srcRect l="0" r="0" t="31577" b="31577"/>
+          <a:srcRect l="0" r="0" t="20545" b="20545"/>
           <a:stretch/>
         </p:blipFill>
         <p:spPr>
@@ -15464,7 +15453,7 @@
       </p:sp>
       <p:pic>
         <p:nvPicPr>
-          <p:cNvPr id="27" name="Digital Metrology" descr="C:\Users\ADMIN\Desktop\TEMP\VSHARK_Website\collateral\assets\digital.jpg">    </p:cNvPr>
+          <p:cNvPr id="27" name="Digital Metrology" descr="C:\Users\ADMIN\Desktop\TEMP\VSHARK_Website\collateral\assets\3d-digital-inspection-deviation-colour-map-of-a-cast-transmission-housing-16x10.jpg">    </p:cNvPr>
           <p:cNvPicPr>
             <a:picLocks noChangeAspect="1"/>
           </p:cNvPicPr>
@@ -15472,7 +15461,7 @@
         </p:nvPicPr>
         <p:blipFill>
           <a:blip r:embed="rId5"/>
-          <a:srcRect l="0" r="0" t="31577" b="31577"/>
+          <a:srcRect l="0" r="0" t="20545" b="20545"/>
           <a:stretch/>
         </p:blipFill>
         <p:spPr>
@@ -15628,7 +15617,7 @@
       </p:sp>
       <p:pic>
         <p:nvPicPr>
-          <p:cNvPr id="32" name="3D Printing" descr="C:\Users\ADMIN\Desktop\TEMP\VSHARK_Website\collateral\assets\printing.jpg">    </p:cNvPr>
+          <p:cNvPr id="32" name="3D Printing" descr="C:\Users\ADMIN\Desktop\TEMP\VSHARK_Website\collateral\assets\resin-3d-printed-prototype-of-an-engine-crankcase-beside-the-original-casting-16x10.jpg">    </p:cNvPr>
           <p:cNvPicPr>
             <a:picLocks noChangeAspect="1"/>
           </p:cNvPicPr>
@@ -15636,7 +15625,7 @@
         </p:nvPicPr>
         <p:blipFill>
           <a:blip r:embed="rId6"/>
-          <a:srcRect l="0" r="0" t="31577" b="31577"/>
+          <a:srcRect l="0" r="0" t="20545" b="20545"/>
           <a:stretch/>
         </p:blipFill>
         <p:spPr>
@@ -15792,7 +15781,7 @@
       </p:sp>
       <p:pic>
         <p:nvPicPr>
-          <p:cNvPr id="37" name="Product Rendering" descr="C:\Users\ADMIN\Desktop\TEMP\VSHARK_Website\collateral\assets\product-rendering.jpg">    </p:cNvPr>
+          <p:cNvPr id="37" name="Product Rendering" descr="C:\Users\ADMIN\Desktop\TEMP\VSHARK_Website\collateral\assets\product-rendering-of-wireless-earbuds-from-clay-model-to-photorealistic-render-16x10.jpg">    </p:cNvPr>
           <p:cNvPicPr>
             <a:picLocks noChangeAspect="1"/>
           </p:cNvPicPr>
@@ -15800,7 +15789,7 @@
         </p:nvPicPr>
         <p:blipFill>
           <a:blip r:embed="rId7"/>
-          <a:srcRect l="0" r="0" t="31577" b="31577"/>
+          <a:srcRect l="0" r="0" t="20545" b="20545"/>
           <a:stretch/>
         </p:blipFill>
         <p:spPr>
@@ -16195,7 +16184,7 @@
       </p:sp>
       <p:pic>
         <p:nvPicPr>
-          <p:cNvPr id="5" name="Step Capture" descr="C:\Users\ADMIN\Desktop\TEMP\VSHARK_Website\collateral\assets\01-scanning.jpg">    </p:cNvPr>
+          <p:cNvPr id="5" name="Step Capture" descr="C:\Users\ADMIN\Desktop\TEMP\VSHARK_Website\collateral\assets\handheld-3d-laser-scanning-of-an-engine-cylinder-head-16x10.jpg">    </p:cNvPr>
           <p:cNvPicPr>
             <a:picLocks noChangeAspect="1"/>
           </p:cNvPicPr>
@@ -16203,7 +16192,7 @@
         </p:nvPicPr>
         <p:blipFill>
           <a:blip r:embed="rId1"/>
-          <a:srcRect l="0" r="0" t="11607" b="11607"/>
+          <a:srcRect l="9273" r="9273" t="0" b="0"/>
           <a:stretch/>
         </p:blipFill>
         <p:spPr>
@@ -16606,7 +16595,7 @@
       </p:sp>
       <p:pic>
         <p:nvPicPr>
-          <p:cNvPr id="17" name="Step Deliver" descr="C:\Users\ADMIN\Desktop\TEMP\VSHARK_Website\collateral\assets\printing.jpg">    </p:cNvPr>
+          <p:cNvPr id="17" name="Step Deliver" descr="C:\Users\ADMIN\Desktop\TEMP\VSHARK_Website\collateral\assets\resin-3d-printed-prototype-of-an-engine-crankcase-beside-the-original-casting-16x10.jpg">    </p:cNvPr>
           <p:cNvPicPr>
             <a:picLocks noChangeAspect="1"/>
           </p:cNvPicPr>
@@ -16614,7 +16603,7 @@
         </p:nvPicPr>
         <p:blipFill>
           <a:blip r:embed="rId4"/>
-          <a:srcRect l="0" r="0" t="11607" b="11607"/>
+          <a:srcRect l="9273" r="9273" t="0" b="0"/>
           <a:stretch/>
         </p:blipFill>
         <p:spPr>
@@ -16898,7 +16887,7 @@
       </p:sp>
       <p:pic>
         <p:nvPicPr>
-          <p:cNvPr id="5" name="3D Scanning" descr="C:\Users\ADMIN\Desktop\TEMP\VSHARK_Website\collateral\assets\01-scanning.jpg">    </p:cNvPr>
+          <p:cNvPr id="5" name="3D Scanning" descr="C:\Users\ADMIN\Desktop\TEMP\VSHARK_Website\collateral\assets\handheld-3d-laser-scanning-of-an-engine-cylinder-head-4x3.jpg">    </p:cNvPr>
           <p:cNvPicPr>
             <a:picLocks noChangeAspect="1"/>
           </p:cNvPicPr>
@@ -16906,13 +16895,13 @@
         </p:nvPicPr>
         <p:blipFill>
           <a:blip r:embed="rId1"/>
-          <a:srcRect l="6911" r="6911" t="0" b="0"/>
+          <a:srcRect l="0" r="0" t="0" b="0"/>
           <a:stretch/>
         </p:blipFill>
         <p:spPr>
           <a:xfrm>
             <a:off x="609905" y="548640"/>
-            <a:ext cx="4846320" cy="5623560"/>
+            <a:ext cx="4846320" cy="3634740"/>
           </a:xfrm>
           <a:prstGeom prst="rect">
             <a:avLst/>
@@ -16927,7 +16916,7 @@
         </p:nvSpPr>
         <p:spPr>
           <a:xfrm>
-            <a:off x="774497" y="5760720"/>
+            <a:off x="774497" y="3813048"/>
             <a:ext cx="1211580" cy="237744"/>
           </a:xfrm>
           <a:prstGeom prst="rect">
@@ -16949,7 +16938,7 @@
         </p:nvSpPr>
         <p:spPr>
           <a:xfrm>
-            <a:off x="774497" y="5760720"/>
+            <a:off x="774497" y="3813048"/>
             <a:ext cx="1211580" cy="237744"/>
           </a:xfrm>
           <a:prstGeom prst="rect">
@@ -17366,7 +17355,7 @@
         </p:nvSpPr>
         <p:spPr>
           <a:xfrm>
-            <a:off x="5806440" y="4892040"/>
+            <a:off x="609905" y="4389120"/>
             <a:ext cx="2743200" cy="182880"/>
           </a:xfrm>
           <a:prstGeom prst="rect">
@@ -17405,7 +17394,7 @@
         </p:nvSpPr>
         <p:spPr>
           <a:xfrm>
-            <a:off x="5806440" y="5120640"/>
+            <a:off x="609905" y="4617720"/>
             <a:ext cx="1836115" cy="274320"/>
           </a:xfrm>
           <a:prstGeom prst="roundRect">
@@ -17432,7 +17421,7 @@
         </p:nvSpPr>
         <p:spPr>
           <a:xfrm>
-            <a:off x="5806440" y="5120640"/>
+            <a:off x="609905" y="4617720"/>
             <a:ext cx="1836115" cy="274320"/>
           </a:xfrm>
           <a:prstGeom prst="rect">
@@ -17468,7 +17457,7 @@
         </p:nvSpPr>
         <p:spPr>
           <a:xfrm>
-            <a:off x="7715707" y="5120640"/>
+            <a:off x="2519172" y="4617720"/>
             <a:ext cx="1375258" cy="274320"/>
           </a:xfrm>
           <a:prstGeom prst="roundRect">
@@ -17495,7 +17484,7 @@
         </p:nvSpPr>
         <p:spPr>
           <a:xfrm>
-            <a:off x="7715707" y="5120640"/>
+            <a:off x="2519172" y="4617720"/>
             <a:ext cx="1375258" cy="274320"/>
           </a:xfrm>
           <a:prstGeom prst="rect">
@@ -17531,7 +17520,7 @@
         </p:nvSpPr>
         <p:spPr>
           <a:xfrm>
-            <a:off x="9164117" y="5120640"/>
+            <a:off x="609905" y="4965192"/>
             <a:ext cx="1572768" cy="274320"/>
           </a:xfrm>
           <a:prstGeom prst="roundRect">
@@ -17558,7 +17547,7 @@
         </p:nvSpPr>
         <p:spPr>
           <a:xfrm>
-            <a:off x="9164117" y="5120640"/>
+            <a:off x="609905" y="4965192"/>
             <a:ext cx="1572768" cy="274320"/>
           </a:xfrm>
           <a:prstGeom prst="rect">
@@ -17594,7 +17583,7 @@
         </p:nvSpPr>
         <p:spPr>
           <a:xfrm>
-            <a:off x="5806440" y="5468112"/>
+            <a:off x="2255825" y="4965192"/>
             <a:ext cx="980237" cy="274320"/>
           </a:xfrm>
           <a:prstGeom prst="roundRect">
@@ -17621,7 +17610,7 @@
         </p:nvSpPr>
         <p:spPr>
           <a:xfrm>
-            <a:off x="5806440" y="5468112"/>
+            <a:off x="2255825" y="4965192"/>
             <a:ext cx="980237" cy="274320"/>
           </a:xfrm>
           <a:prstGeom prst="rect">
@@ -17657,7 +17646,7 @@
         </p:nvSpPr>
         <p:spPr>
           <a:xfrm>
-            <a:off x="5806440" y="5852160"/>
+            <a:off x="609905" y="5367528"/>
             <a:ext cx="2743200" cy="182880"/>
           </a:xfrm>
           <a:prstGeom prst="rect">
@@ -17696,7 +17685,7 @@
         </p:nvSpPr>
         <p:spPr>
           <a:xfrm>
-            <a:off x="5806440" y="6080760"/>
+            <a:off x="609905" y="5596128"/>
             <a:ext cx="848563" cy="274320"/>
           </a:xfrm>
           <a:prstGeom prst="roundRect">
@@ -17723,7 +17712,7 @@
         </p:nvSpPr>
         <p:spPr>
           <a:xfrm>
-            <a:off x="5806440" y="6080760"/>
+            <a:off x="609905" y="5596128"/>
             <a:ext cx="848563" cy="274320"/>
           </a:xfrm>
           <a:prstGeom prst="rect">
@@ -17759,7 +17748,7 @@
         </p:nvSpPr>
         <p:spPr>
           <a:xfrm>
-            <a:off x="6728155" y="6080760"/>
+            <a:off x="1531620" y="5596128"/>
             <a:ext cx="914400" cy="274320"/>
           </a:xfrm>
           <a:prstGeom prst="roundRect">
@@ -17786,7 +17775,7 @@
         </p:nvSpPr>
         <p:spPr>
           <a:xfrm>
-            <a:off x="6728155" y="6080760"/>
+            <a:off x="1531620" y="5596128"/>
             <a:ext cx="914400" cy="274320"/>
           </a:xfrm>
           <a:prstGeom prst="rect">
@@ -17822,7 +17811,7 @@
         </p:nvSpPr>
         <p:spPr>
           <a:xfrm>
-            <a:off x="7715707" y="6080760"/>
+            <a:off x="2519172" y="5596128"/>
             <a:ext cx="914400" cy="274320"/>
           </a:xfrm>
           <a:prstGeom prst="roundRect">
@@ -17849,7 +17838,7 @@
         </p:nvSpPr>
         <p:spPr>
           <a:xfrm>
-            <a:off x="7715707" y="6080760"/>
+            <a:off x="2519172" y="5596128"/>
             <a:ext cx="914400" cy="274320"/>
           </a:xfrm>
           <a:prstGeom prst="rect">
@@ -17885,7 +17874,7 @@
         </p:nvSpPr>
         <p:spPr>
           <a:xfrm>
-            <a:off x="8703259" y="6080760"/>
+            <a:off x="3506724" y="5596128"/>
             <a:ext cx="848563" cy="274320"/>
           </a:xfrm>
           <a:prstGeom prst="roundRect">
@@ -17912,7 +17901,7 @@
         </p:nvSpPr>
         <p:spPr>
           <a:xfrm>
-            <a:off x="8703259" y="6080760"/>
+            <a:off x="3506724" y="5596128"/>
             <a:ext cx="848563" cy="274320"/>
           </a:xfrm>
           <a:prstGeom prst="rect">
@@ -17948,7 +17937,7 @@
         </p:nvSpPr>
         <p:spPr>
           <a:xfrm>
-            <a:off x="9624974" y="6080760"/>
+            <a:off x="4428439" y="5596128"/>
             <a:ext cx="848563" cy="274320"/>
           </a:xfrm>
           <a:prstGeom prst="roundRect">
@@ -17975,7 +17964,7 @@
         </p:nvSpPr>
         <p:spPr>
           <a:xfrm>
-            <a:off x="9624974" y="6080760"/>
+            <a:off x="4428439" y="5596128"/>
             <a:ext cx="848563" cy="274320"/>
           </a:xfrm>
           <a:prstGeom prst="rect">
@@ -18160,7 +18149,7 @@
       </p:sp>
       <p:pic>
         <p:nvPicPr>
-          <p:cNvPr id="5" name="Reverse Engineering" descr="C:\Users\ADMIN\Desktop\TEMP\VSHARK_Website\collateral\assets\02-reverse-engineering.jpg">    </p:cNvPr>
+          <p:cNvPr id="5" name="Reverse Engineering" descr="C:\Users\ADMIN\Desktop\TEMP\VSHARK_Website\collateral\assets\3d-scan-to-cad-reverse-engineering-of-a-motorcycle-tubular-frame-4x3.jpg">    </p:cNvPr>
           <p:cNvPicPr>
             <a:picLocks noChangeAspect="1"/>
           </p:cNvPicPr>
@@ -18168,13 +18157,13 @@
         </p:nvPicPr>
         <p:blipFill>
           <a:blip r:embed="rId1"/>
-          <a:srcRect l="6911" r="6911" t="0" b="0"/>
+          <a:srcRect l="0" r="0" t="0" b="0"/>
           <a:stretch/>
         </p:blipFill>
         <p:spPr>
           <a:xfrm>
             <a:off x="609905" y="548640"/>
-            <a:ext cx="4846320" cy="5623560"/>
+            <a:ext cx="4846320" cy="3634740"/>
           </a:xfrm>
           <a:prstGeom prst="rect">
             <a:avLst/>
@@ -18189,7 +18178,7 @@
         </p:nvSpPr>
         <p:spPr>
           <a:xfrm>
-            <a:off x="774497" y="5760720"/>
+            <a:off x="774497" y="3813048"/>
             <a:ext cx="1211580" cy="237744"/>
           </a:xfrm>
           <a:prstGeom prst="rect">
@@ -18211,7 +18200,7 @@
         </p:nvSpPr>
         <p:spPr>
           <a:xfrm>
-            <a:off x="774497" y="5760720"/>
+            <a:off x="774497" y="3813048"/>
             <a:ext cx="1211580" cy="237744"/>
           </a:xfrm>
           <a:prstGeom prst="rect">
@@ -18628,7 +18617,7 @@
         </p:nvSpPr>
         <p:spPr>
           <a:xfrm>
-            <a:off x="5806440" y="4892040"/>
+            <a:off x="609905" y="4389120"/>
             <a:ext cx="2743200" cy="182880"/>
           </a:xfrm>
           <a:prstGeom prst="rect">
@@ -18667,7 +18656,7 @@
         </p:nvSpPr>
         <p:spPr>
           <a:xfrm>
-            <a:off x="5806440" y="5120640"/>
+            <a:off x="609905" y="4617720"/>
             <a:ext cx="2560320" cy="274320"/>
           </a:xfrm>
           <a:prstGeom prst="roundRect">
@@ -18694,7 +18683,7 @@
         </p:nvSpPr>
         <p:spPr>
           <a:xfrm>
-            <a:off x="5806440" y="5120640"/>
+            <a:off x="609905" y="4617720"/>
             <a:ext cx="2560320" cy="274320"/>
           </a:xfrm>
           <a:prstGeom prst="rect">
@@ -18730,7 +18719,7 @@
         </p:nvSpPr>
         <p:spPr>
           <a:xfrm>
-            <a:off x="8439912" y="5120640"/>
+            <a:off x="3243377" y="4617720"/>
             <a:ext cx="1309421" cy="274320"/>
           </a:xfrm>
           <a:prstGeom prst="roundRect">
@@ -18757,7 +18746,7 @@
         </p:nvSpPr>
         <p:spPr>
           <a:xfrm>
-            <a:off x="8439912" y="5120640"/>
+            <a:off x="3243377" y="4617720"/>
             <a:ext cx="1309421" cy="274320"/>
           </a:xfrm>
           <a:prstGeom prst="rect">
@@ -18793,7 +18782,7 @@
         </p:nvSpPr>
         <p:spPr>
           <a:xfrm>
-            <a:off x="5806440" y="5468112"/>
+            <a:off x="609905" y="4965192"/>
             <a:ext cx="1836115" cy="274320"/>
           </a:xfrm>
           <a:prstGeom prst="roundRect">
@@ -18820,7 +18809,7 @@
         </p:nvSpPr>
         <p:spPr>
           <a:xfrm>
-            <a:off x="5806440" y="5468112"/>
+            <a:off x="609905" y="4965192"/>
             <a:ext cx="1836115" cy="274320"/>
           </a:xfrm>
           <a:prstGeom prst="rect">
@@ -18856,7 +18845,7 @@
         </p:nvSpPr>
         <p:spPr>
           <a:xfrm>
-            <a:off x="7715707" y="5468112"/>
+            <a:off x="2519172" y="4965192"/>
             <a:ext cx="1901952" cy="274320"/>
           </a:xfrm>
           <a:prstGeom prst="roundRect">
@@ -18883,7 +18872,7 @@
         </p:nvSpPr>
         <p:spPr>
           <a:xfrm>
-            <a:off x="7715707" y="5468112"/>
+            <a:off x="2519172" y="4965192"/>
             <a:ext cx="1901952" cy="274320"/>
           </a:xfrm>
           <a:prstGeom prst="rect">
@@ -18919,7 +18908,7 @@
         </p:nvSpPr>
         <p:spPr>
           <a:xfrm>
-            <a:off x="5806440" y="5852160"/>
+            <a:off x="609905" y="5367528"/>
             <a:ext cx="2743200" cy="182880"/>
           </a:xfrm>
           <a:prstGeom prst="rect">
@@ -18958,7 +18947,7 @@
         </p:nvSpPr>
         <p:spPr>
           <a:xfrm>
-            <a:off x="5806440" y="6080760"/>
+            <a:off x="609905" y="5596128"/>
             <a:ext cx="914400" cy="274320"/>
           </a:xfrm>
           <a:prstGeom prst="roundRect">
@@ -18985,7 +18974,7 @@
         </p:nvSpPr>
         <p:spPr>
           <a:xfrm>
-            <a:off x="5806440" y="6080760"/>
+            <a:off x="609905" y="5596128"/>
             <a:ext cx="914400" cy="274320"/>
           </a:xfrm>
           <a:prstGeom prst="rect">
@@ -19021,7 +19010,7 @@
         </p:nvSpPr>
         <p:spPr>
           <a:xfrm>
-            <a:off x="6793992" y="6080760"/>
+            <a:off x="1597457" y="5596128"/>
             <a:ext cx="848563" cy="274320"/>
           </a:xfrm>
           <a:prstGeom prst="roundRect">
@@ -19048,7 +19037,7 @@
         </p:nvSpPr>
         <p:spPr>
           <a:xfrm>
-            <a:off x="6793992" y="6080760"/>
+            <a:off x="1597457" y="5596128"/>
             <a:ext cx="848563" cy="274320"/>
           </a:xfrm>
           <a:prstGeom prst="rect">
@@ -19084,7 +19073,7 @@
         </p:nvSpPr>
         <p:spPr>
           <a:xfrm>
-            <a:off x="7715707" y="6080760"/>
+            <a:off x="2519172" y="5596128"/>
             <a:ext cx="914400" cy="274320"/>
           </a:xfrm>
           <a:prstGeom prst="roundRect">
@@ -19111,7 +19100,7 @@
         </p:nvSpPr>
         <p:spPr>
           <a:xfrm>
-            <a:off x="7715707" y="6080760"/>
+            <a:off x="2519172" y="5596128"/>
             <a:ext cx="914400" cy="274320"/>
           </a:xfrm>
           <a:prstGeom prst="rect">
@@ -19296,7 +19285,7 @@
       </p:sp>
       <p:pic>
         <p:nvPicPr>
-          <p:cNvPr id="5" name="Scan to BIM" descr="C:\Users\ADMIN\Desktop\TEMP\VSHARK_Website\collateral\assets\bim.jpg">    </p:cNvPr>
+          <p:cNvPr id="5" name="Scan to BIM" descr="C:\Users\ADMIN\Desktop\TEMP\VSHARK_Website\collateral\assets\terrestrial-laser-scanning-of-an-industrial-pump-room-for-scan-to-bim-4x3.jpg">    </p:cNvPr>
           <p:cNvPicPr>
             <a:picLocks noChangeAspect="1"/>
           </p:cNvPicPr>
@@ -19304,13 +19293,13 @@
         </p:nvPicPr>
         <p:blipFill>
           <a:blip r:embed="rId1"/>
-          <a:srcRect l="6911" r="6911" t="0" b="0"/>
+          <a:srcRect l="0" r="0" t="0" b="0"/>
           <a:stretch/>
         </p:blipFill>
         <p:spPr>
           <a:xfrm>
             <a:off x="609905" y="548640"/>
-            <a:ext cx="4846320" cy="5623560"/>
+            <a:ext cx="4846320" cy="3634740"/>
           </a:xfrm>
           <a:prstGeom prst="rect">
             <a:avLst/>
@@ -19325,7 +19314,7 @@
         </p:nvSpPr>
         <p:spPr>
           <a:xfrm>
-            <a:off x="774497" y="5760720"/>
+            <a:off x="774497" y="3813048"/>
             <a:ext cx="1211580" cy="237744"/>
           </a:xfrm>
           <a:prstGeom prst="rect">
@@ -19347,7 +19336,7 @@
         </p:nvSpPr>
         <p:spPr>
           <a:xfrm>
-            <a:off x="774497" y="5760720"/>
+            <a:off x="774497" y="3813048"/>
             <a:ext cx="1211580" cy="237744"/>
           </a:xfrm>
           <a:prstGeom prst="rect">
@@ -19764,7 +19753,7 @@
         </p:nvSpPr>
         <p:spPr>
           <a:xfrm>
-            <a:off x="5806440" y="4892040"/>
+            <a:off x="609905" y="4389120"/>
             <a:ext cx="2743200" cy="182880"/>
           </a:xfrm>
           <a:prstGeom prst="rect">
@@ -19803,7 +19792,7 @@
         </p:nvSpPr>
         <p:spPr>
           <a:xfrm>
-            <a:off x="5806440" y="5120640"/>
+            <a:off x="609905" y="4617720"/>
             <a:ext cx="2560320" cy="274320"/>
           </a:xfrm>
           <a:prstGeom prst="roundRect">
@@ -19830,7 +19819,7 @@
         </p:nvSpPr>
         <p:spPr>
           <a:xfrm>
-            <a:off x="5806440" y="5120640"/>
+            <a:off x="609905" y="4617720"/>
             <a:ext cx="2560320" cy="274320"/>
           </a:xfrm>
           <a:prstGeom prst="rect">
@@ -19866,7 +19855,7 @@
         </p:nvSpPr>
         <p:spPr>
           <a:xfrm>
-            <a:off x="8439912" y="5120640"/>
+            <a:off x="3243377" y="4617720"/>
             <a:ext cx="1441094" cy="274320"/>
           </a:xfrm>
           <a:prstGeom prst="roundRect">
@@ -19893,7 +19882,7 @@
         </p:nvSpPr>
         <p:spPr>
           <a:xfrm>
-            <a:off x="8439912" y="5120640"/>
+            <a:off x="3243377" y="4617720"/>
             <a:ext cx="1441094" cy="274320"/>
           </a:xfrm>
           <a:prstGeom prst="rect">
@@ -19929,7 +19918,7 @@
         </p:nvSpPr>
         <p:spPr>
           <a:xfrm>
-            <a:off x="9954158" y="5120640"/>
+            <a:off x="609905" y="4965192"/>
             <a:ext cx="914400" cy="274320"/>
           </a:xfrm>
           <a:prstGeom prst="roundRect">
@@ -19956,7 +19945,7 @@
         </p:nvSpPr>
         <p:spPr>
           <a:xfrm>
-            <a:off x="9954158" y="5120640"/>
+            <a:off x="609905" y="4965192"/>
             <a:ext cx="914400" cy="274320"/>
           </a:xfrm>
           <a:prstGeom prst="rect">
@@ -19992,7 +19981,7 @@
         </p:nvSpPr>
         <p:spPr>
           <a:xfrm>
-            <a:off x="5806440" y="5468112"/>
+            <a:off x="1597457" y="4965192"/>
             <a:ext cx="2231136" cy="274320"/>
           </a:xfrm>
           <a:prstGeom prst="roundRect">
@@ -20019,7 +20008,7 @@
         </p:nvSpPr>
         <p:spPr>
           <a:xfrm>
-            <a:off x="5806440" y="5468112"/>
+            <a:off x="1597457" y="4965192"/>
             <a:ext cx="2231136" cy="274320"/>
           </a:xfrm>
           <a:prstGeom prst="rect">
@@ -20055,7 +20044,7 @@
         </p:nvSpPr>
         <p:spPr>
           <a:xfrm>
-            <a:off x="5806440" y="5852160"/>
+            <a:off x="609905" y="5367528"/>
             <a:ext cx="2743200" cy="182880"/>
           </a:xfrm>
           <a:prstGeom prst="rect">
@@ -20094,7 +20083,7 @@
         </p:nvSpPr>
         <p:spPr>
           <a:xfrm>
-            <a:off x="5806440" y="6080760"/>
+            <a:off x="609905" y="5596128"/>
             <a:ext cx="1046074" cy="274320"/>
           </a:xfrm>
           <a:prstGeom prst="roundRect">
@@ -20121,7 +20110,7 @@
         </p:nvSpPr>
         <p:spPr>
           <a:xfrm>
-            <a:off x="5806440" y="6080760"/>
+            <a:off x="609905" y="5596128"/>
             <a:ext cx="1046074" cy="274320"/>
           </a:xfrm>
           <a:prstGeom prst="rect">
@@ -20157,7 +20146,7 @@
         </p:nvSpPr>
         <p:spPr>
           <a:xfrm>
-            <a:off x="6925666" y="6080760"/>
+            <a:off x="1729130" y="5596128"/>
             <a:ext cx="848563" cy="274320"/>
           </a:xfrm>
           <a:prstGeom prst="roundRect">
@@ -20184,7 +20173,7 @@
         </p:nvSpPr>
         <p:spPr>
           <a:xfrm>
-            <a:off x="6925666" y="6080760"/>
+            <a:off x="1729130" y="5596128"/>
             <a:ext cx="848563" cy="274320"/>
           </a:xfrm>
           <a:prstGeom prst="rect">
@@ -20220,7 +20209,7 @@
         </p:nvSpPr>
         <p:spPr>
           <a:xfrm>
-            <a:off x="7847381" y="6080760"/>
+            <a:off x="2650846" y="5596128"/>
             <a:ext cx="914400" cy="274320"/>
           </a:xfrm>
           <a:prstGeom prst="roundRect">
@@ -20247,7 +20236,7 @@
         </p:nvSpPr>
         <p:spPr>
           <a:xfrm>
-            <a:off x="7847381" y="6080760"/>
+            <a:off x="2650846" y="5596128"/>
             <a:ext cx="914400" cy="274320"/>
           </a:xfrm>
           <a:prstGeom prst="rect">
@@ -20432,7 +20421,7 @@
       </p:sp>
       <p:pic>
         <p:nvPicPr>
-          <p:cNvPr id="5" name="Class A Surfacing" descr="C:\Users\ADMIN\Desktop\TEMP\VSHARK_Website\collateral\assets\class-a.jpg">    </p:cNvPr>
+          <p:cNvPr id="5" name="Class A Surfacing" descr="C:\Users\ADMIN\Desktop\TEMP\VSHARK_Website\collateral\assets\class-a-surface-zebra-stripe-analysis-of-a-car-fender-4x3.jpg">    </p:cNvPr>
           <p:cNvPicPr>
             <a:picLocks noChangeAspect="1"/>
           </p:cNvPicPr>
@@ -20440,13 +20429,13 @@
         </p:nvPicPr>
         <p:blipFill>
           <a:blip r:embed="rId1"/>
-          <a:srcRect l="6911" r="6911" t="0" b="0"/>
+          <a:srcRect l="0" r="0" t="0" b="0"/>
           <a:stretch/>
         </p:blipFill>
         <p:spPr>
           <a:xfrm>
             <a:off x="609905" y="548640"/>
-            <a:ext cx="4846320" cy="5623560"/>
+            <a:ext cx="4846320" cy="3634740"/>
           </a:xfrm>
           <a:prstGeom prst="rect">
             <a:avLst/>
@@ -20461,7 +20450,7 @@
         </p:nvSpPr>
         <p:spPr>
           <a:xfrm>
-            <a:off x="774497" y="5760720"/>
+            <a:off x="774497" y="3813048"/>
             <a:ext cx="1211580" cy="237744"/>
           </a:xfrm>
           <a:prstGeom prst="rect">
@@ -20483,7 +20472,7 @@
         </p:nvSpPr>
         <p:spPr>
           <a:xfrm>
-            <a:off x="774497" y="5760720"/>
+            <a:off x="774497" y="3813048"/>
             <a:ext cx="1211580" cy="237744"/>
           </a:xfrm>
           <a:prstGeom prst="rect">
@@ -20900,7 +20889,7 @@
         </p:nvSpPr>
         <p:spPr>
           <a:xfrm>
-            <a:off x="5806440" y="4892040"/>
+            <a:off x="609905" y="4389120"/>
             <a:ext cx="2743200" cy="182880"/>
           </a:xfrm>
           <a:prstGeom prst="rect">
@@ -20939,7 +20928,7 @@
         </p:nvSpPr>
         <p:spPr>
           <a:xfrm>
-            <a:off x="5806440" y="5120640"/>
+            <a:off x="609905" y="4617720"/>
             <a:ext cx="2296973" cy="274320"/>
           </a:xfrm>
           <a:prstGeom prst="roundRect">
@@ -20966,7 +20955,7 @@
         </p:nvSpPr>
         <p:spPr>
           <a:xfrm>
-            <a:off x="5806440" y="5120640"/>
+            <a:off x="609905" y="4617720"/>
             <a:ext cx="2296973" cy="274320"/>
           </a:xfrm>
           <a:prstGeom prst="rect">
@@ -21002,7 +20991,7 @@
         </p:nvSpPr>
         <p:spPr>
           <a:xfrm>
-            <a:off x="8176565" y="5120640"/>
+            <a:off x="2980030" y="4617720"/>
             <a:ext cx="1836115" cy="274320"/>
           </a:xfrm>
           <a:prstGeom prst="roundRect">
@@ -21029,7 +21018,7 @@
         </p:nvSpPr>
         <p:spPr>
           <a:xfrm>
-            <a:off x="8176565" y="5120640"/>
+            <a:off x="2980030" y="4617720"/>
             <a:ext cx="1836115" cy="274320"/>
           </a:xfrm>
           <a:prstGeom prst="rect">
@@ -21065,7 +21054,7 @@
         </p:nvSpPr>
         <p:spPr>
           <a:xfrm>
-            <a:off x="10085832" y="5120640"/>
+            <a:off x="609905" y="4965192"/>
             <a:ext cx="1441094" cy="274320"/>
           </a:xfrm>
           <a:prstGeom prst="roundRect">
@@ -21092,7 +21081,7 @@
         </p:nvSpPr>
         <p:spPr>
           <a:xfrm>
-            <a:off x="10085832" y="5120640"/>
+            <a:off x="609905" y="4965192"/>
             <a:ext cx="1441094" cy="274320"/>
           </a:xfrm>
           <a:prstGeom prst="rect">
@@ -21128,7 +21117,7 @@
         </p:nvSpPr>
         <p:spPr>
           <a:xfrm>
-            <a:off x="5806440" y="5504688"/>
+            <a:off x="609905" y="5367528"/>
             <a:ext cx="2743200" cy="182880"/>
           </a:xfrm>
           <a:prstGeom prst="rect">
@@ -21167,7 +21156,7 @@
         </p:nvSpPr>
         <p:spPr>
           <a:xfrm>
-            <a:off x="5806440" y="5733288"/>
+            <a:off x="609905" y="5596128"/>
             <a:ext cx="914400" cy="274320"/>
           </a:xfrm>
           <a:prstGeom prst="roundRect">
@@ -21194,7 +21183,7 @@
         </p:nvSpPr>
         <p:spPr>
           <a:xfrm>
-            <a:off x="5806440" y="5733288"/>
+            <a:off x="609905" y="5596128"/>
             <a:ext cx="914400" cy="274320"/>
           </a:xfrm>
           <a:prstGeom prst="rect">
@@ -21230,7 +21219,7 @@
         </p:nvSpPr>
         <p:spPr>
           <a:xfrm>
-            <a:off x="6793992" y="5733288"/>
+            <a:off x="1597457" y="5596128"/>
             <a:ext cx="848563" cy="274320"/>
           </a:xfrm>
           <a:prstGeom prst="roundRect">
@@ -21257,7 +21246,7 @@
         </p:nvSpPr>
         <p:spPr>
           <a:xfrm>
-            <a:off x="6793992" y="5733288"/>
+            <a:off x="1597457" y="5596128"/>
             <a:ext cx="848563" cy="274320"/>
           </a:xfrm>
           <a:prstGeom prst="rect">
@@ -21442,7 +21431,7 @@
       </p:sp>
       <p:pic>
         <p:nvPicPr>
-          <p:cNvPr id="5" name="Digital Metrology" descr="C:\Users\ADMIN\Desktop\TEMP\VSHARK_Website\collateral\assets\digital.jpg">    </p:cNvPr>
+          <p:cNvPr id="5" name="Digital Metrology" descr="C:\Users\ADMIN\Desktop\TEMP\VSHARK_Website\collateral\assets\3d-digital-inspection-deviation-colour-map-of-a-cast-transmission-housing-4x3.jpg">    </p:cNvPr>
           <p:cNvPicPr>
             <a:picLocks noChangeAspect="1"/>
           </p:cNvPicPr>
@@ -21450,13 +21439,13 @@
         </p:nvPicPr>
         <p:blipFill>
           <a:blip r:embed="rId1"/>
-          <a:srcRect l="6911" r="6911" t="0" b="0"/>
+          <a:srcRect l="0" r="0" t="0" b="0"/>
           <a:stretch/>
         </p:blipFill>
         <p:spPr>
           <a:xfrm>
             <a:off x="609905" y="548640"/>
-            <a:ext cx="4846320" cy="5623560"/>
+            <a:ext cx="4846320" cy="3634740"/>
           </a:xfrm>
           <a:prstGeom prst="rect">
             <a:avLst/>
@@ -21471,7 +21460,7 @@
         </p:nvSpPr>
         <p:spPr>
           <a:xfrm>
-            <a:off x="774497" y="5760720"/>
+            <a:off x="774497" y="3813048"/>
             <a:ext cx="1211580" cy="237744"/>
           </a:xfrm>
           <a:prstGeom prst="rect">
@@ -21493,7 +21482,7 @@
         </p:nvSpPr>
         <p:spPr>
           <a:xfrm>
-            <a:off x="774497" y="5760720"/>
+            <a:off x="774497" y="3813048"/>
             <a:ext cx="1211580" cy="237744"/>
           </a:xfrm>
           <a:prstGeom prst="rect">
@@ -21910,7 +21899,7 @@
         </p:nvSpPr>
         <p:spPr>
           <a:xfrm>
-            <a:off x="5806440" y="4892040"/>
+            <a:off x="609905" y="4389120"/>
             <a:ext cx="2743200" cy="182880"/>
           </a:xfrm>
           <a:prstGeom prst="rect">
@@ -21949,7 +21938,7 @@
         </p:nvSpPr>
         <p:spPr>
           <a:xfrm>
-            <a:off x="5806440" y="5120640"/>
+            <a:off x="609905" y="4617720"/>
             <a:ext cx="1836115" cy="274320"/>
           </a:xfrm>
           <a:prstGeom prst="roundRect">
@@ -21976,7 +21965,7 @@
         </p:nvSpPr>
         <p:spPr>
           <a:xfrm>
-            <a:off x="5806440" y="5120640"/>
+            <a:off x="609905" y="4617720"/>
             <a:ext cx="1836115" cy="274320"/>
           </a:xfrm>
           <a:prstGeom prst="rect">
@@ -22012,7 +22001,7 @@
         </p:nvSpPr>
         <p:spPr>
           <a:xfrm>
-            <a:off x="7715707" y="5120640"/>
+            <a:off x="2519172" y="4617720"/>
             <a:ext cx="1638605" cy="274320"/>
           </a:xfrm>
           <a:prstGeom prst="roundRect">
@@ -22039,7 +22028,7 @@
         </p:nvSpPr>
         <p:spPr>
           <a:xfrm>
-            <a:off x="7715707" y="5120640"/>
+            <a:off x="2519172" y="4617720"/>
             <a:ext cx="1638605" cy="274320"/>
           </a:xfrm>
           <a:prstGeom prst="rect">
@@ -22075,7 +22064,7 @@
         </p:nvSpPr>
         <p:spPr>
           <a:xfrm>
-            <a:off x="9427464" y="5120640"/>
+            <a:off x="609905" y="4965192"/>
             <a:ext cx="1506931" cy="274320"/>
           </a:xfrm>
           <a:prstGeom prst="roundRect">
@@ -22102,7 +22091,7 @@
         </p:nvSpPr>
         <p:spPr>
           <a:xfrm>
-            <a:off x="9427464" y="5120640"/>
+            <a:off x="609905" y="4965192"/>
             <a:ext cx="1506931" cy="274320"/>
           </a:xfrm>
           <a:prstGeom prst="rect">
@@ -22138,7 +22127,7 @@
         </p:nvSpPr>
         <p:spPr>
           <a:xfrm>
-            <a:off x="5806440" y="5468112"/>
+            <a:off x="2189988" y="4965192"/>
             <a:ext cx="1638605" cy="274320"/>
           </a:xfrm>
           <a:prstGeom prst="roundRect">
@@ -22165,7 +22154,7 @@
         </p:nvSpPr>
         <p:spPr>
           <a:xfrm>
-            <a:off x="5806440" y="5468112"/>
+            <a:off x="2189988" y="4965192"/>
             <a:ext cx="1638605" cy="274320"/>
           </a:xfrm>
           <a:prstGeom prst="rect">
@@ -22201,7 +22190,7 @@
         </p:nvSpPr>
         <p:spPr>
           <a:xfrm>
-            <a:off x="5806440" y="5852160"/>
+            <a:off x="609905" y="5367528"/>
             <a:ext cx="2743200" cy="182880"/>
           </a:xfrm>
           <a:prstGeom prst="rect">
@@ -22240,7 +22229,7 @@
         </p:nvSpPr>
         <p:spPr>
           <a:xfrm>
-            <a:off x="5806440" y="6080760"/>
+            <a:off x="609905" y="5596128"/>
             <a:ext cx="848563" cy="274320"/>
           </a:xfrm>
           <a:prstGeom prst="roundRect">
@@ -22267,7 +22256,7 @@
         </p:nvSpPr>
         <p:spPr>
           <a:xfrm>
-            <a:off x="5806440" y="6080760"/>
+            <a:off x="609905" y="5596128"/>
             <a:ext cx="848563" cy="274320"/>
           </a:xfrm>
           <a:prstGeom prst="rect">
@@ -22303,7 +22292,7 @@
         </p:nvSpPr>
         <p:spPr>
           <a:xfrm>
-            <a:off x="6728155" y="6080760"/>
+            <a:off x="1531620" y="5596128"/>
             <a:ext cx="914400" cy="274320"/>
           </a:xfrm>
           <a:prstGeom prst="roundRect">
@@ -22330,7 +22319,7 @@
         </p:nvSpPr>
         <p:spPr>
           <a:xfrm>
-            <a:off x="6728155" y="6080760"/>
+            <a:off x="1531620" y="5596128"/>
             <a:ext cx="914400" cy="274320"/>
           </a:xfrm>
           <a:prstGeom prst="rect">
@@ -22366,7 +22355,7 @@
         </p:nvSpPr>
         <p:spPr>
           <a:xfrm>
-            <a:off x="7715707" y="6080760"/>
+            <a:off x="2519172" y="5596128"/>
             <a:ext cx="914400" cy="274320"/>
           </a:xfrm>
           <a:prstGeom prst="roundRect">
@@ -22393,7 +22382,7 @@
         </p:nvSpPr>
         <p:spPr>
           <a:xfrm>
-            <a:off x="7715707" y="6080760"/>
+            <a:off x="2519172" y="5596128"/>
             <a:ext cx="914400" cy="274320"/>
           </a:xfrm>
           <a:prstGeom prst="rect">

</xml_diff>

<commit_message>
Collateral: use the new Motorcycle Tubular Frame project
Co-Authored-By: Claude Opus 5.5 <noreply@anthropic.com>
</commit_message>
<xml_diff>
--- a/collateral/VShark-Presentation.pptx
+++ b/collateral/VShark-Presentation.pptx
@@ -123,13 +123,13 @@
   <p:extLst>
     <p:ext uri="{521415D9-36F7-43E2-AB2F-B90AF26B5E84}">
       <p14:sectionLst xmlns:p14="http://schemas.microsoft.com/office/powerpoint/2010/main">
-        <p14:section name="Introduction" id="{c00043f8-1041-fddd-42d6-cbeae92b8166}">
+        <p14:section name="Introduction" id="{31b16417-1b17-0fc4-79de-5dd76ad541a9}">
           <p14:sldIdLst>
             <p14:sldId id="256"/>
             <p14:sldId id="257"/>
           </p14:sldIdLst>
         </p14:section>
-        <p14:section name="Services" id="{e1707035-784d-6ab9-d43c-f8f0b444c795}">
+        <p14:section name="Services" id="{bcd33af1-1b90-37c2-c750-f5619a14087e}">
           <p14:sldIdLst>
             <p14:sldId id="258"/>
             <p14:sldId id="259"/>
@@ -142,19 +142,19 @@
             <p14:sldId id="266"/>
           </p14:sldIdLst>
         </p14:section>
-        <p14:section name="Portfolio" id="{dd6fcbd6-6d85-231c-e618-ffc29640bdbc}">
+        <p14:section name="Portfolio" id="{8ab532e2-6ef9-1488-2019-ae8d420f7325}">
           <p14:sldIdLst>
             <p14:sldId id="267"/>
             <p14:sldId id="268"/>
           </p14:sldIdLst>
         </p14:section>
-        <p14:section name="Industries &amp; products" id="{5e568033-0814-d0d2-cddf-7bd885ea9fb1}">
+        <p14:section name="Industries &amp; products" id="{0b857351-7537-00b1-f081-8485739b9a69}">
           <p14:sldIdLst>
             <p14:sldId id="269"/>
             <p14:sldId id="270"/>
           </p14:sldIdLst>
         </p14:section>
-        <p14:section name="Clients &amp; contact" id="{7a56c259-cbb5-cc50-4fc9-7f11f2ed8ad4}">
+        <p14:section name="Clients &amp; contact" id="{c4cab50c-53d1-d89a-7063-2f1fee7a60f3}">
           <p14:sldIdLst>
             <p14:sldId id="271"/>
             <p14:sldId id="272"/>
@@ -6531,7 +6531,7 @@
       </p:sp>
       <p:pic>
         <p:nvPicPr>
-          <p:cNvPr id="20" name="Motorcycle Frame scan" descr="C:\Users\ADMIN\Desktop\TEMP\VSHARK_Website\collateral\assets\bike-scan.jpg">    </p:cNvPr>
+          <p:cNvPr id="20" name="Motorcycle Tubular Frame scan" descr="C:\Users\ADMIN\Desktop\TEMP\VSHARK_Website\collateral\assets\3d-scan-of-a-motorcycle-tubular-frame.jpg">    </p:cNvPr>
           <p:cNvPicPr>
             <a:picLocks noChangeAspect="1"/>
           </p:cNvPicPr>
@@ -6554,7 +6554,7 @@
       </p:pic>
       <p:pic>
         <p:nvPicPr>
-          <p:cNvPr id="21" name="Motorcycle Frame CAD" descr="C:\Users\ADMIN\Desktop\TEMP\VSHARK_Website\collateral\assets\bike-cad.jpg">    </p:cNvPr>
+          <p:cNvPr id="21" name="Motorcycle Tubular Frame CAD" descr="C:\Users\ADMIN\Desktop\TEMP\VSHARK_Website\collateral\assets\cad-model-of-a-motorcycle-tubular-frame.jpg">    </p:cNvPr>
           <p:cNvPicPr>
             <a:picLocks noChangeAspect="1"/>
           </p:cNvPicPr>
@@ -6728,7 +6728,7 @@
                 <a:ea typeface="Century Gothic" pitchFamily="34" charset="-122"/>
                 <a:cs typeface="Century Gothic" pitchFamily="34" charset="-120"/>
               </a:rPr>
-              <a:t>Motorcycle Frame  </a:t>
+              <a:t>Motorcycle Tubular Frame  </a:t>
             </a:r>
             <a:pPr indent="0" marL="0">
               <a:buNone/>
@@ -6739,7 +6739,7 @@
                   <a:schemeClr val="accent3"/>
                 </a:solidFill>
               </a:rPr>
-              <a:t>Motorcycle frame digitised and converted into an editable CAD assembly.</a:t>
+              <a:t>Tubular motorcycle frame digitised and converted into an editable CAD model.</a:t>
             </a:r>
             <a:endParaRPr lang="en-US" sz="1100" dirty="0"/>
           </a:p>

</xml_diff>